<commit_message>
Update VT-02 System Virtualization.pptx
</commit_message>
<xml_diff>
--- a/Slides/CSC6103/VT-02 System Virtualization.pptx
+++ b/Slides/CSC6103/VT-02 System Virtualization.pptx
@@ -5,10 +5,10 @@
     <p:sldMasterId id="2147483660" r:id="rId1"/>
   </p:sldMasterIdLst>
   <p:notesMasterIdLst>
-    <p:notesMasterId r:id="rId49"/>
+    <p:notesMasterId r:id="rId48"/>
   </p:notesMasterIdLst>
   <p:handoutMasterIdLst>
-    <p:handoutMasterId r:id="rId50"/>
+    <p:handoutMasterId r:id="rId49"/>
   </p:handoutMasterIdLst>
   <p:sldIdLst>
     <p:sldId id="256" r:id="rId2"/>
@@ -27,37 +27,36 @@
     <p:sldId id="557" r:id="rId15"/>
     <p:sldId id="520" r:id="rId16"/>
     <p:sldId id="521" r:id="rId17"/>
-    <p:sldId id="559" r:id="rId18"/>
-    <p:sldId id="522" r:id="rId19"/>
-    <p:sldId id="523" r:id="rId20"/>
-    <p:sldId id="560" r:id="rId21"/>
-    <p:sldId id="525" r:id="rId22"/>
-    <p:sldId id="526" r:id="rId23"/>
-    <p:sldId id="527" r:id="rId24"/>
-    <p:sldId id="529" r:id="rId25"/>
-    <p:sldId id="561" r:id="rId26"/>
-    <p:sldId id="530" r:id="rId27"/>
-    <p:sldId id="531" r:id="rId28"/>
-    <p:sldId id="532" r:id="rId29"/>
-    <p:sldId id="533" r:id="rId30"/>
-    <p:sldId id="562" r:id="rId31"/>
-    <p:sldId id="534" r:id="rId32"/>
-    <p:sldId id="535" r:id="rId33"/>
-    <p:sldId id="536" r:id="rId34"/>
-    <p:sldId id="537" r:id="rId35"/>
-    <p:sldId id="538" r:id="rId36"/>
-    <p:sldId id="540" r:id="rId37"/>
-    <p:sldId id="541" r:id="rId38"/>
-    <p:sldId id="543" r:id="rId39"/>
-    <p:sldId id="544" r:id="rId40"/>
-    <p:sldId id="545" r:id="rId41"/>
-    <p:sldId id="546" r:id="rId42"/>
-    <p:sldId id="547" r:id="rId43"/>
-    <p:sldId id="563" r:id="rId44"/>
-    <p:sldId id="550" r:id="rId45"/>
-    <p:sldId id="564" r:id="rId46"/>
-    <p:sldId id="553" r:id="rId47"/>
-    <p:sldId id="554" r:id="rId48"/>
+    <p:sldId id="522" r:id="rId18"/>
+    <p:sldId id="523" r:id="rId19"/>
+    <p:sldId id="560" r:id="rId20"/>
+    <p:sldId id="525" r:id="rId21"/>
+    <p:sldId id="526" r:id="rId22"/>
+    <p:sldId id="527" r:id="rId23"/>
+    <p:sldId id="529" r:id="rId24"/>
+    <p:sldId id="561" r:id="rId25"/>
+    <p:sldId id="530" r:id="rId26"/>
+    <p:sldId id="531" r:id="rId27"/>
+    <p:sldId id="532" r:id="rId28"/>
+    <p:sldId id="533" r:id="rId29"/>
+    <p:sldId id="562" r:id="rId30"/>
+    <p:sldId id="534" r:id="rId31"/>
+    <p:sldId id="535" r:id="rId32"/>
+    <p:sldId id="536" r:id="rId33"/>
+    <p:sldId id="537" r:id="rId34"/>
+    <p:sldId id="538" r:id="rId35"/>
+    <p:sldId id="540" r:id="rId36"/>
+    <p:sldId id="541" r:id="rId37"/>
+    <p:sldId id="543" r:id="rId38"/>
+    <p:sldId id="544" r:id="rId39"/>
+    <p:sldId id="545" r:id="rId40"/>
+    <p:sldId id="546" r:id="rId41"/>
+    <p:sldId id="547" r:id="rId42"/>
+    <p:sldId id="563" r:id="rId43"/>
+    <p:sldId id="550" r:id="rId44"/>
+    <p:sldId id="564" r:id="rId45"/>
+    <p:sldId id="553" r:id="rId46"/>
+    <p:sldId id="554" r:id="rId47"/>
   </p:sldIdLst>
   <p:sldSz cx="9144000" cy="5143500" type="screen16x9"/>
   <p:notesSz cx="6858000" cy="9144000"/>
@@ -266,7 +265,7 @@
             <a:fld id="{45BDCE37-E9BE-4280-8D68-34E43D66CEDB}" type="datetimeFigureOut">
               <a:rPr lang="zh-TW" altLang="en-US" smtClean="0"/>
               <a:pPr/>
-              <a:t>2026/9/9</a:t>
+              <a:t>2026/9/16</a:t>
             </a:fld>
             <a:endParaRPr lang="zh-TW" altLang="en-US"/>
           </a:p>
@@ -433,7 +432,7 @@
             <a:fld id="{FBFBA883-381C-409E-9635-BB54B21745E4}" type="datetimeFigureOut">
               <a:rPr lang="zh-TW" altLang="en-US" smtClean="0"/>
               <a:pPr/>
-              <a:t>2026/9/9</a:t>
+              <a:t>2026/9/16</a:t>
             </a:fld>
             <a:endParaRPr lang="zh-TW" altLang="en-US"/>
           </a:p>
@@ -917,7 +916,7 @@
               </a14:hiddenLine>
             </a:ext>
             <a:ext uri="{FAA26D3D-D897-4be2-8F04-BA451C77F1D7}">
-              <ma14:placeholderFlag xmlns:ma14="http://schemas.microsoft.com/office/mac/drawingml/2011/main" xmlns="" val="1"/>
+              <ma14:placeholderFlag xmlns="" xmlns:ma14="http://schemas.microsoft.com/office/mac/drawingml/2011/main" val="1"/>
             </a:ext>
           </a:extLst>
         </p:spPr>
@@ -5587,8 +5586,8 @@
         </p:nvSpPr>
         <p:spPr>
           <a:xfrm>
-            <a:off x="773084" y="861602"/>
-            <a:ext cx="7852729" cy="2660531"/>
+            <a:off x="773084" y="815882"/>
+            <a:ext cx="7852729" cy="3748498"/>
           </a:xfrm>
         </p:spPr>
         <p:txBody>
@@ -5597,8 +5596,13 @@
           </a:bodyPr>
           <a:lstStyle/>
           <a:p>
-            <a:r>
-              <a:rPr lang="en-US" sz="2200" dirty="0">
+            <a:pPr>
+              <a:spcBef>
+                <a:spcPts val="0"/>
+              </a:spcBef>
+            </a:pPr>
+            <a:r>
+              <a:rPr lang="en-US" sz="2000" dirty="0">
                 <a:latin typeface="Times New Roman" panose="02020603050405020304" pitchFamily="18" charset="0"/>
                 <a:cs typeface="Times New Roman" panose="02020603050405020304" pitchFamily="18" charset="0"/>
               </a:rPr>
@@ -5607,11 +5611,14 @@
           </a:p>
           <a:p>
             <a:pPr marL="685800" lvl="1" indent="-274320">
+              <a:spcBef>
+                <a:spcPts val="0"/>
+              </a:spcBef>
               <a:buFont typeface="+mj-lt"/>
               <a:buAutoNum type="arabicPeriod"/>
             </a:pPr>
             <a:r>
-              <a:rPr lang="en-US" sz="2000" dirty="0">
+              <a:rPr lang="en-US" sz="1800" dirty="0">
                 <a:latin typeface="Times New Roman" panose="02020603050405020304" pitchFamily="18" charset="0"/>
                 <a:cs typeface="Times New Roman" panose="02020603050405020304" pitchFamily="18" charset="0"/>
               </a:rPr>
@@ -5620,11 +5627,14 @@
           </a:p>
           <a:p>
             <a:pPr marL="685800" lvl="1" indent="-274320">
+              <a:spcBef>
+                <a:spcPts val="0"/>
+              </a:spcBef>
               <a:buFont typeface="+mj-lt"/>
               <a:buAutoNum type="arabicPeriod"/>
             </a:pPr>
             <a:r>
-              <a:rPr lang="en-US" sz="2000" dirty="0">
+              <a:rPr lang="en-US" sz="1800" dirty="0">
                 <a:latin typeface="Times New Roman" panose="02020603050405020304" pitchFamily="18" charset="0"/>
                 <a:cs typeface="Times New Roman" panose="02020603050405020304" pitchFamily="18" charset="0"/>
               </a:rPr>
@@ -5633,11 +5643,14 @@
           </a:p>
           <a:p>
             <a:pPr marL="685800" lvl="1" indent="-274320">
+              <a:spcBef>
+                <a:spcPts val="0"/>
+              </a:spcBef>
               <a:buFont typeface="+mj-lt"/>
               <a:buAutoNum type="arabicPeriod"/>
             </a:pPr>
             <a:r>
-              <a:rPr lang="en-US" sz="2000" dirty="0">
+              <a:rPr lang="en-US" sz="1800" dirty="0">
                 <a:latin typeface="Times New Roman" panose="02020603050405020304" pitchFamily="18" charset="0"/>
                 <a:cs typeface="Times New Roman" panose="02020603050405020304" pitchFamily="18" charset="0"/>
               </a:rPr>
@@ -5646,11 +5659,14 @@
           </a:p>
           <a:p>
             <a:pPr marL="685800" lvl="1" indent="-274320">
+              <a:spcBef>
+                <a:spcPts val="0"/>
+              </a:spcBef>
               <a:buFont typeface="+mj-lt"/>
               <a:buAutoNum type="arabicPeriod"/>
             </a:pPr>
             <a:r>
-              <a:rPr lang="en-US" sz="2000" dirty="0">
+              <a:rPr lang="en-US" sz="1800" dirty="0">
                 <a:latin typeface="Times New Roman" panose="02020603050405020304" pitchFamily="18" charset="0"/>
                 <a:cs typeface="Times New Roman" panose="02020603050405020304" pitchFamily="18" charset="0"/>
               </a:rPr>
@@ -5659,17 +5675,104 @@
           </a:p>
           <a:p>
             <a:pPr marL="685800" lvl="1" indent="-274320">
+              <a:spcBef>
+                <a:spcPts val="0"/>
+              </a:spcBef>
               <a:buFont typeface="+mj-lt"/>
               <a:buAutoNum type="arabicPeriod"/>
             </a:pPr>
             <a:r>
-              <a:rPr lang="en-US" sz="2000" dirty="0">
+              <a:rPr lang="en-US" sz="1800" dirty="0">
                 <a:latin typeface="Times New Roman" panose="02020603050405020304" pitchFamily="18" charset="0"/>
                 <a:cs typeface="Times New Roman" panose="02020603050405020304" pitchFamily="18" charset="0"/>
               </a:rPr>
               <a:t>Execute the translated host instruction block in code cache.</a:t>
             </a:r>
-            <a:endParaRPr lang="en-US" dirty="0">
+          </a:p>
+          <a:p>
+            <a:pPr>
+              <a:spcBef>
+                <a:spcPts val="600"/>
+              </a:spcBef>
+            </a:pPr>
+            <a:r>
+              <a:rPr lang="en-US" altLang="zh-CN" sz="2000" dirty="0">
+                <a:latin typeface="Times New Roman" panose="02020603050405020304" pitchFamily="18" charset="0"/>
+                <a:cs typeface="Times New Roman" panose="02020603050405020304" pitchFamily="18" charset="0"/>
+              </a:rPr>
+              <a:t>Pros &amp; Cons</a:t>
+            </a:r>
+          </a:p>
+          <a:p>
+            <a:pPr lvl="1">
+              <a:spcBef>
+                <a:spcPts val="0"/>
+              </a:spcBef>
+            </a:pPr>
+            <a:r>
+              <a:rPr lang="en-US" altLang="zh-CN" sz="1800" dirty="0">
+                <a:latin typeface="Times New Roman" panose="02020603050405020304" pitchFamily="18" charset="0"/>
+                <a:cs typeface="Times New Roman" panose="02020603050405020304" pitchFamily="18" charset="0"/>
+              </a:rPr>
+              <a:t>Pros</a:t>
+            </a:r>
+          </a:p>
+          <a:p>
+            <a:pPr lvl="2">
+              <a:spcBef>
+                <a:spcPts val="0"/>
+              </a:spcBef>
+            </a:pPr>
+            <a:r>
+              <a:rPr lang="en-US" altLang="zh-CN" sz="1800" dirty="0">
+                <a:latin typeface="Times New Roman" panose="02020603050405020304" pitchFamily="18" charset="0"/>
+                <a:cs typeface="Times New Roman" panose="02020603050405020304" pitchFamily="18" charset="0"/>
+              </a:rPr>
+              <a:t>Emulator can reuse the translated host code</a:t>
+            </a:r>
+          </a:p>
+          <a:p>
+            <a:pPr lvl="2">
+              <a:spcBef>
+                <a:spcPts val="0"/>
+              </a:spcBef>
+            </a:pPr>
+            <a:r>
+              <a:rPr lang="en-US" altLang="zh-CN" sz="1800" dirty="0">
+                <a:latin typeface="Times New Roman" panose="02020603050405020304" pitchFamily="18" charset="0"/>
+                <a:cs typeface="Times New Roman" panose="02020603050405020304" pitchFamily="18" charset="0"/>
+              </a:rPr>
+              <a:t>Emulator can apply more optimization when translating guest blocks</a:t>
+            </a:r>
+          </a:p>
+          <a:p>
+            <a:pPr lvl="1">
+              <a:spcBef>
+                <a:spcPts val="0"/>
+              </a:spcBef>
+            </a:pPr>
+            <a:r>
+              <a:rPr lang="en-US" altLang="zh-CN" sz="1800" dirty="0">
+                <a:latin typeface="Times New Roman" panose="02020603050405020304" pitchFamily="18" charset="0"/>
+                <a:cs typeface="Times New Roman" panose="02020603050405020304" pitchFamily="18" charset="0"/>
+              </a:rPr>
+              <a:t>Cons</a:t>
+            </a:r>
+          </a:p>
+          <a:p>
+            <a:pPr lvl="2">
+              <a:spcBef>
+                <a:spcPts val="0"/>
+              </a:spcBef>
+            </a:pPr>
+            <a:r>
+              <a:rPr lang="en-US" altLang="zh-CN" sz="1800" dirty="0">
+                <a:latin typeface="Times New Roman" panose="02020603050405020304" pitchFamily="18" charset="0"/>
+                <a:cs typeface="Times New Roman" panose="02020603050405020304" pitchFamily="18" charset="0"/>
+              </a:rPr>
+              <a:t>Implementation complexity will increase</a:t>
+            </a:r>
+            <a:endParaRPr lang="en-US" sz="1800" dirty="0">
               <a:latin typeface="Times New Roman" panose="02020603050405020304" pitchFamily="18" charset="0"/>
               <a:cs typeface="Times New Roman" panose="02020603050405020304" pitchFamily="18" charset="0"/>
             </a:endParaRPr>
@@ -5753,180 +5856,6 @@
         </p:nvSpPr>
         <p:spPr>
           <a:xfrm>
-            <a:off x="914400" y="108349"/>
-            <a:ext cx="7761290" cy="519113"/>
-          </a:xfrm>
-        </p:spPr>
-        <p:txBody>
-          <a:bodyPr/>
-          <a:lstStyle/>
-          <a:p>
-            <a:r>
-              <a:rPr lang="en-US" dirty="0"/>
-              <a:t>Static Binary Translation (3)</a:t>
-            </a:r>
-          </a:p>
-        </p:txBody>
-      </p:sp>
-      <p:sp>
-        <p:nvSpPr>
-          <p:cNvPr id="3" name="Content Placeholder 2"/>
-          <p:cNvSpPr>
-            <a:spLocks noGrp="1"/>
-          </p:cNvSpPr>
-          <p:nvPr>
-            <p:ph idx="1"/>
-          </p:nvPr>
-        </p:nvSpPr>
-        <p:spPr>
-          <a:xfrm>
-            <a:off x="914399" y="835822"/>
-            <a:ext cx="7414953" cy="2763590"/>
-          </a:xfrm>
-        </p:spPr>
-        <p:txBody>
-          <a:bodyPr>
-            <a:noAutofit/>
-          </a:bodyPr>
-          <a:lstStyle/>
-          <a:p>
-            <a:r>
-              <a:rPr lang="en-US" sz="2200" dirty="0">
-                <a:latin typeface="Times New Roman" panose="02020603050405020304" pitchFamily="18" charset="0"/>
-                <a:cs typeface="Times New Roman" panose="02020603050405020304" pitchFamily="18" charset="0"/>
-              </a:rPr>
-              <a:t>Pros &amp; Cons</a:t>
-            </a:r>
-          </a:p>
-          <a:p>
-            <a:pPr lvl="1"/>
-            <a:r>
-              <a:rPr lang="en-US" sz="2000" dirty="0">
-                <a:latin typeface="Times New Roman" panose="02020603050405020304" pitchFamily="18" charset="0"/>
-                <a:cs typeface="Times New Roman" panose="02020603050405020304" pitchFamily="18" charset="0"/>
-              </a:rPr>
-              <a:t>Pros</a:t>
-            </a:r>
-          </a:p>
-          <a:p>
-            <a:pPr lvl="2"/>
-            <a:r>
-              <a:rPr lang="en-US" sz="1800" dirty="0">
-                <a:latin typeface="Times New Roman" panose="02020603050405020304" pitchFamily="18" charset="0"/>
-                <a:cs typeface="Times New Roman" panose="02020603050405020304" pitchFamily="18" charset="0"/>
-              </a:rPr>
-              <a:t>Emulator can reuse the translated host code</a:t>
-            </a:r>
-          </a:p>
-          <a:p>
-            <a:pPr lvl="2"/>
-            <a:r>
-              <a:rPr lang="en-US" sz="1800" dirty="0">
-                <a:latin typeface="Times New Roman" panose="02020603050405020304" pitchFamily="18" charset="0"/>
-                <a:cs typeface="Times New Roman" panose="02020603050405020304" pitchFamily="18" charset="0"/>
-              </a:rPr>
-              <a:t>Emulator can apply more optimization when translating guest blocks</a:t>
-            </a:r>
-          </a:p>
-          <a:p>
-            <a:pPr lvl="1"/>
-            <a:r>
-              <a:rPr lang="en-US" sz="2000" dirty="0">
-                <a:latin typeface="Times New Roman" panose="02020603050405020304" pitchFamily="18" charset="0"/>
-                <a:cs typeface="Times New Roman" panose="02020603050405020304" pitchFamily="18" charset="0"/>
-              </a:rPr>
-              <a:t>Cons</a:t>
-            </a:r>
-          </a:p>
-          <a:p>
-            <a:pPr lvl="2"/>
-            <a:r>
-              <a:rPr lang="en-US" sz="1800" dirty="0">
-                <a:latin typeface="Times New Roman" panose="02020603050405020304" pitchFamily="18" charset="0"/>
-                <a:cs typeface="Times New Roman" panose="02020603050405020304" pitchFamily="18" charset="0"/>
-              </a:rPr>
-              <a:t>Implementation complexity will increase</a:t>
-            </a:r>
-          </a:p>
-        </p:txBody>
-      </p:sp>
-      <p:sp>
-        <p:nvSpPr>
-          <p:cNvPr id="4" name="灯片编号占位符 1">
-            <a:extLst>
-              <a:ext uri="{FF2B5EF4-FFF2-40B4-BE49-F238E27FC236}">
-                <a16:creationId xmlns:a16="http://schemas.microsoft.com/office/drawing/2014/main" id="{59DE8E2A-BDBF-D0C3-24E2-D8F2160B5972}"/>
-              </a:ext>
-            </a:extLst>
-          </p:cNvPr>
-          <p:cNvSpPr>
-            <a:spLocks noGrp="1"/>
-          </p:cNvSpPr>
-          <p:nvPr>
-            <p:ph type="sldNum" sz="quarter" idx="10"/>
-          </p:nvPr>
-        </p:nvSpPr>
-        <p:spPr>
-          <a:xfrm>
-            <a:off x="6831013" y="4893471"/>
-            <a:ext cx="2133600" cy="254794"/>
-          </a:xfrm>
-        </p:spPr>
-        <p:txBody>
-          <a:bodyPr/>
-          <a:lstStyle/>
-          <a:p>
-            <a:fld id="{D9B6BDF2-6896-4B98-8776-C18582F63BA5}" type="slidenum">
-              <a:rPr lang="zh-TW" altLang="en-US" smtClean="0"/>
-              <a:pPr/>
-              <a:t>17</a:t>
-            </a:fld>
-            <a:endParaRPr lang="zh-TW" altLang="en-US"/>
-          </a:p>
-        </p:txBody>
-      </p:sp>
-    </p:spTree>
-    <p:extLst>
-      <p:ext uri="{BB962C8B-B14F-4D97-AF65-F5344CB8AC3E}">
-        <p14:creationId xmlns:p14="http://schemas.microsoft.com/office/powerpoint/2010/main" val="580761312"/>
-      </p:ext>
-    </p:extLst>
-  </p:cSld>
-  <p:clrMapOvr>
-    <a:masterClrMapping/>
-  </p:clrMapOvr>
-</p:sld>
-</file>
-
-<file path=ppt/slides/slide18.xml><?xml version="1.0" encoding="utf-8"?>
-<p:sld xmlns:a="http://schemas.openxmlformats.org/drawingml/2006/main" xmlns:r="http://schemas.openxmlformats.org/officeDocument/2006/relationships" xmlns:p="http://schemas.openxmlformats.org/presentationml/2006/main">
-  <p:cSld>
-    <p:spTree>
-      <p:nvGrpSpPr>
-        <p:cNvPr id="1" name=""/>
-        <p:cNvGrpSpPr/>
-        <p:nvPr/>
-      </p:nvGrpSpPr>
-      <p:grpSpPr>
-        <a:xfrm>
-          <a:off x="0" y="0"/>
-          <a:ext cx="0" cy="0"/>
-          <a:chOff x="0" y="0"/>
-          <a:chExt cx="0" cy="0"/>
-        </a:xfrm>
-      </p:grpSpPr>
-      <p:sp>
-        <p:nvSpPr>
-          <p:cNvPr id="2" name="Title 1"/>
-          <p:cNvSpPr>
-            <a:spLocks noGrp="1"/>
-          </p:cNvSpPr>
-          <p:nvPr>
-            <p:ph type="title"/>
-          </p:nvPr>
-        </p:nvSpPr>
-        <p:spPr>
-          <a:xfrm>
             <a:off x="897775" y="108349"/>
             <a:ext cx="7777915" cy="519113"/>
           </a:xfrm>
@@ -5937,7 +5866,7 @@
           <a:p>
             <a:r>
               <a:rPr lang="en-US" dirty="0"/>
-              <a:t>Static Binary Translation (4)</a:t>
+              <a:t>Static Binary Translation (3)</a:t>
             </a:r>
           </a:p>
         </p:txBody>
@@ -6091,7 +6020,7 @@
             <a:fld id="{D9B6BDF2-6896-4B98-8776-C18582F63BA5}" type="slidenum">
               <a:rPr lang="zh-TW" altLang="en-US" smtClean="0"/>
               <a:pPr/>
-              <a:t>18</a:t>
+              <a:t>17</a:t>
             </a:fld>
             <a:endParaRPr lang="zh-TW" altLang="en-US" dirty="0"/>
           </a:p>
@@ -6243,7 +6172,7 @@
 </p:sld>
 </file>
 
-<file path=ppt/slides/slide19.xml><?xml version="1.0" encoding="utf-8"?>
+<file path=ppt/slides/slide18.xml><?xml version="1.0" encoding="utf-8"?>
 <p:sld xmlns:a="http://schemas.openxmlformats.org/drawingml/2006/main" xmlns:r="http://schemas.openxmlformats.org/officeDocument/2006/relationships" xmlns:p="http://schemas.openxmlformats.org/presentationml/2006/main">
   <p:cSld>
     <p:spTree>
@@ -6309,6 +6238,11 @@
           <a:bodyPr/>
           <a:lstStyle/>
           <a:p>
+            <a:pPr>
+              <a:spcBef>
+                <a:spcPts val="0"/>
+              </a:spcBef>
+            </a:pPr>
             <a:r>
               <a:rPr lang="en-US" sz="2400" dirty="0">
                 <a:latin typeface="Times New Roman" panose="02020603050405020304" pitchFamily="18" charset="0"/>
@@ -6329,6 +6263,9 @@
           </a:p>
           <a:p>
             <a:pPr marL="0" indent="0">
+              <a:spcBef>
+                <a:spcPts val="0"/>
+              </a:spcBef>
               <a:buNone/>
             </a:pPr>
             <a:br>
@@ -6344,6 +6281,9 @@
           </a:p>
           <a:p>
             <a:pPr marL="0" indent="0">
+              <a:spcBef>
+                <a:spcPts val="0"/>
+              </a:spcBef>
               <a:buNone/>
             </a:pPr>
             <a:endParaRPr lang="en-US" sz="2400" dirty="0">
@@ -6352,6 +6292,11 @@
             </a:endParaRPr>
           </a:p>
           <a:p>
+            <a:pPr>
+              <a:spcBef>
+                <a:spcPts val="0"/>
+              </a:spcBef>
+            </a:pPr>
             <a:r>
               <a:rPr lang="en-US" sz="2400" dirty="0">
                 <a:latin typeface="Times New Roman" panose="02020603050405020304" pitchFamily="18" charset="0"/>
@@ -6379,7 +6324,7 @@
         </p:blipFill>
         <p:spPr bwMode="auto">
           <a:xfrm>
-            <a:off x="2851265" y="1389802"/>
+            <a:off x="2851265" y="1359322"/>
             <a:ext cx="3298876" cy="1256767"/>
           </a:xfrm>
           <a:prstGeom prst="rect">
@@ -6412,7 +6357,7 @@
         </p:blipFill>
         <p:spPr bwMode="auto">
           <a:xfrm>
-            <a:off x="2094807" y="3296061"/>
+            <a:off x="2094807" y="3197001"/>
             <a:ext cx="5384980" cy="1282995"/>
           </a:xfrm>
           <a:prstGeom prst="rect">
@@ -6457,7 +6402,7 @@
             <a:fld id="{D9B6BDF2-6896-4B98-8776-C18582F63BA5}" type="slidenum">
               <a:rPr lang="zh-TW" altLang="en-US" smtClean="0"/>
               <a:pPr/>
-              <a:t>19</a:t>
+              <a:t>18</a:t>
             </a:fld>
             <a:endParaRPr lang="zh-TW" altLang="en-US"/>
           </a:p>
@@ -6467,6 +6412,189 @@
     <p:extLst>
       <p:ext uri="{BB962C8B-B14F-4D97-AF65-F5344CB8AC3E}">
         <p14:creationId xmlns:p14="http://schemas.microsoft.com/office/powerpoint/2010/main" val="827283099"/>
+      </p:ext>
+    </p:extLst>
+  </p:cSld>
+  <p:clrMapOvr>
+    <a:masterClrMapping/>
+  </p:clrMapOvr>
+</p:sld>
+</file>
+
+<file path=ppt/slides/slide19.xml><?xml version="1.0" encoding="utf-8"?>
+<p:sld xmlns:a="http://schemas.openxmlformats.org/drawingml/2006/main" xmlns:r="http://schemas.openxmlformats.org/officeDocument/2006/relationships" xmlns:p="http://schemas.openxmlformats.org/presentationml/2006/main">
+  <p:cSld>
+    <p:spTree>
+      <p:nvGrpSpPr>
+        <p:cNvPr id="1" name=""/>
+        <p:cNvGrpSpPr/>
+        <p:nvPr/>
+      </p:nvGrpSpPr>
+      <p:grpSpPr>
+        <a:xfrm>
+          <a:off x="0" y="0"/>
+          <a:ext cx="0" cy="0"/>
+          <a:chOff x="0" y="0"/>
+          <a:chExt cx="0" cy="0"/>
+        </a:xfrm>
+      </p:grpSpPr>
+      <p:sp>
+        <p:nvSpPr>
+          <p:cNvPr id="2" name="Title 1"/>
+          <p:cNvSpPr>
+            <a:spLocks noGrp="1"/>
+          </p:cNvSpPr>
+          <p:nvPr>
+            <p:ph type="title"/>
+          </p:nvPr>
+        </p:nvSpPr>
+        <p:spPr>
+          <a:xfrm>
+            <a:off x="916587" y="98724"/>
+            <a:ext cx="7836105" cy="519113"/>
+          </a:xfrm>
+        </p:spPr>
+        <p:txBody>
+          <a:bodyPr/>
+          <a:lstStyle/>
+          <a:p>
+            <a:r>
+              <a:rPr lang="en-US" dirty="0"/>
+              <a:t>Dynamic Binary Translation (1)</a:t>
+            </a:r>
+          </a:p>
+        </p:txBody>
+      </p:sp>
+      <p:sp>
+        <p:nvSpPr>
+          <p:cNvPr id="3" name="Content Placeholder 2"/>
+          <p:cNvSpPr>
+            <a:spLocks noGrp="1"/>
+          </p:cNvSpPr>
+          <p:nvPr>
+            <p:ph idx="1"/>
+          </p:nvPr>
+        </p:nvSpPr>
+        <p:spPr>
+          <a:xfrm>
+            <a:off x="947651" y="821002"/>
+            <a:ext cx="7414954" cy="3568118"/>
+          </a:xfrm>
+        </p:spPr>
+        <p:txBody>
+          <a:bodyPr>
+            <a:noAutofit/>
+          </a:bodyPr>
+          <a:lstStyle/>
+          <a:p>
+            <a:r>
+              <a:rPr lang="en-US" sz="2000" dirty="0">
+                <a:latin typeface="Times New Roman" panose="02020603050405020304" pitchFamily="18" charset="0"/>
+                <a:cs typeface="Times New Roman" panose="02020603050405020304" pitchFamily="18" charset="0"/>
+              </a:rPr>
+              <a:t>A hybrid implementation</a:t>
+            </a:r>
+          </a:p>
+          <a:p>
+            <a:pPr lvl="1"/>
+            <a:r>
+              <a:rPr lang="en-US" sz="1800" dirty="0">
+                <a:latin typeface="Times New Roman" panose="02020603050405020304" pitchFamily="18" charset="0"/>
+                <a:cs typeface="Times New Roman" panose="02020603050405020304" pitchFamily="18" charset="0"/>
+              </a:rPr>
+              <a:t>For the first discovered codes, directly interpret by interpreter and record these codes as discovered</a:t>
+            </a:r>
+          </a:p>
+          <a:p>
+            <a:pPr lvl="1"/>
+            <a:r>
+              <a:rPr lang="en-US" sz="1800" dirty="0">
+                <a:latin typeface="Times New Roman" panose="02020603050405020304" pitchFamily="18" charset="0"/>
+                <a:cs typeface="Times New Roman" panose="02020603050405020304" pitchFamily="18" charset="0"/>
+              </a:rPr>
+              <a:t>As the guest codes discovered, trigger the binary translation module to translate the guest code blocks to host code blocks, and place them into code cache</a:t>
+            </a:r>
+          </a:p>
+          <a:p>
+            <a:pPr lvl="1"/>
+            <a:r>
+              <a:rPr lang="en-US" sz="1800" dirty="0">
+                <a:latin typeface="Times New Roman" panose="02020603050405020304" pitchFamily="18" charset="0"/>
+                <a:cs typeface="Times New Roman" panose="02020603050405020304" pitchFamily="18" charset="0"/>
+              </a:rPr>
+              <a:t>When execute the translated block of guest code next time, jump to the code cache and execute the translated host binary code</a:t>
+            </a:r>
+          </a:p>
+          <a:p>
+            <a:r>
+              <a:rPr lang="en-US" sz="2000" dirty="0">
+                <a:latin typeface="Times New Roman" panose="02020603050405020304" pitchFamily="18" charset="0"/>
+                <a:cs typeface="Times New Roman" panose="02020603050405020304" pitchFamily="18" charset="0"/>
+              </a:rPr>
+              <a:t>Pros &amp; Cons</a:t>
+            </a:r>
+          </a:p>
+          <a:p>
+            <a:pPr lvl="1"/>
+            <a:r>
+              <a:rPr lang="en-US" sz="1800" dirty="0">
+                <a:latin typeface="Times New Roman" panose="02020603050405020304" pitchFamily="18" charset="0"/>
+                <a:cs typeface="Times New Roman" panose="02020603050405020304" pitchFamily="18" charset="0"/>
+              </a:rPr>
+              <a:t>Pros : Transparently implement binary translation</a:t>
+            </a:r>
+          </a:p>
+          <a:p>
+            <a:pPr lvl="1"/>
+            <a:r>
+              <a:rPr lang="en-US" sz="1800" dirty="0">
+                <a:latin typeface="Times New Roman" panose="02020603050405020304" pitchFamily="18" charset="0"/>
+                <a:cs typeface="Times New Roman" panose="02020603050405020304" pitchFamily="18" charset="0"/>
+              </a:rPr>
+              <a:t>Cons : Hard to implement</a:t>
+            </a:r>
+          </a:p>
+        </p:txBody>
+      </p:sp>
+      <p:sp>
+        <p:nvSpPr>
+          <p:cNvPr id="4" name="灯片编号占位符 1">
+            <a:extLst>
+              <a:ext uri="{FF2B5EF4-FFF2-40B4-BE49-F238E27FC236}">
+                <a16:creationId xmlns:a16="http://schemas.microsoft.com/office/drawing/2014/main" id="{2FEF5301-2C84-013F-5F50-7D65316DFEDE}"/>
+              </a:ext>
+            </a:extLst>
+          </p:cNvPr>
+          <p:cNvSpPr>
+            <a:spLocks noGrp="1"/>
+          </p:cNvSpPr>
+          <p:nvPr>
+            <p:ph type="sldNum" sz="quarter" idx="10"/>
+          </p:nvPr>
+        </p:nvSpPr>
+        <p:spPr>
+          <a:xfrm>
+            <a:off x="6831013" y="4893471"/>
+            <a:ext cx="2133600" cy="254794"/>
+          </a:xfrm>
+        </p:spPr>
+        <p:txBody>
+          <a:bodyPr/>
+          <a:lstStyle/>
+          <a:p>
+            <a:fld id="{D9B6BDF2-6896-4B98-8776-C18582F63BA5}" type="slidenum">
+              <a:rPr lang="zh-TW" altLang="en-US" smtClean="0"/>
+              <a:pPr/>
+              <a:t>19</a:t>
+            </a:fld>
+            <a:endParaRPr lang="zh-TW" altLang="en-US"/>
+          </a:p>
+        </p:txBody>
+      </p:sp>
+    </p:spTree>
+    <p:extLst>
+      <p:ext uri="{BB962C8B-B14F-4D97-AF65-F5344CB8AC3E}">
+        <p14:creationId xmlns:p14="http://schemas.microsoft.com/office/powerpoint/2010/main" val="1419940445"/>
       </p:ext>
     </p:extLst>
   </p:cSld>
@@ -6670,189 +6798,6 @@
         </p:nvSpPr>
         <p:spPr>
           <a:xfrm>
-            <a:off x="916587" y="98724"/>
-            <a:ext cx="7836105" cy="519113"/>
-          </a:xfrm>
-        </p:spPr>
-        <p:txBody>
-          <a:bodyPr/>
-          <a:lstStyle/>
-          <a:p>
-            <a:r>
-              <a:rPr lang="en-US" dirty="0"/>
-              <a:t>Dynamic Binary Translation (1)</a:t>
-            </a:r>
-          </a:p>
-        </p:txBody>
-      </p:sp>
-      <p:sp>
-        <p:nvSpPr>
-          <p:cNvPr id="3" name="Content Placeholder 2"/>
-          <p:cNvSpPr>
-            <a:spLocks noGrp="1"/>
-          </p:cNvSpPr>
-          <p:nvPr>
-            <p:ph idx="1"/>
-          </p:nvPr>
-        </p:nvSpPr>
-        <p:spPr>
-          <a:xfrm>
-            <a:off x="947651" y="821002"/>
-            <a:ext cx="7414954" cy="3568118"/>
-          </a:xfrm>
-        </p:spPr>
-        <p:txBody>
-          <a:bodyPr>
-            <a:noAutofit/>
-          </a:bodyPr>
-          <a:lstStyle/>
-          <a:p>
-            <a:r>
-              <a:rPr lang="en-US" sz="2000" dirty="0">
-                <a:latin typeface="Times New Roman" panose="02020603050405020304" pitchFamily="18" charset="0"/>
-                <a:cs typeface="Times New Roman" panose="02020603050405020304" pitchFamily="18" charset="0"/>
-              </a:rPr>
-              <a:t>A hybrid implementation</a:t>
-            </a:r>
-          </a:p>
-          <a:p>
-            <a:pPr lvl="1"/>
-            <a:r>
-              <a:rPr lang="en-US" sz="1800" dirty="0">
-                <a:latin typeface="Times New Roman" panose="02020603050405020304" pitchFamily="18" charset="0"/>
-                <a:cs typeface="Times New Roman" panose="02020603050405020304" pitchFamily="18" charset="0"/>
-              </a:rPr>
-              <a:t>For the first discovered codes, directly interpret by interpreter and record these codes as discovered</a:t>
-            </a:r>
-          </a:p>
-          <a:p>
-            <a:pPr lvl="1"/>
-            <a:r>
-              <a:rPr lang="en-US" sz="1800" dirty="0">
-                <a:latin typeface="Times New Roman" panose="02020603050405020304" pitchFamily="18" charset="0"/>
-                <a:cs typeface="Times New Roman" panose="02020603050405020304" pitchFamily="18" charset="0"/>
-              </a:rPr>
-              <a:t>As the guest codes discovered, trigger the binary translation module to translate the guest code blocks to host code blocks, and place them into code cache</a:t>
-            </a:r>
-          </a:p>
-          <a:p>
-            <a:pPr lvl="1"/>
-            <a:r>
-              <a:rPr lang="en-US" sz="1800" dirty="0">
-                <a:latin typeface="Times New Roman" panose="02020603050405020304" pitchFamily="18" charset="0"/>
-                <a:cs typeface="Times New Roman" panose="02020603050405020304" pitchFamily="18" charset="0"/>
-              </a:rPr>
-              <a:t>When execute the translated block of guest code next time, jump to the code cache and execute the translated host binary code</a:t>
-            </a:r>
-          </a:p>
-          <a:p>
-            <a:r>
-              <a:rPr lang="en-US" sz="2000" dirty="0">
-                <a:latin typeface="Times New Roman" panose="02020603050405020304" pitchFamily="18" charset="0"/>
-                <a:cs typeface="Times New Roman" panose="02020603050405020304" pitchFamily="18" charset="0"/>
-              </a:rPr>
-              <a:t>Pros &amp; Cons</a:t>
-            </a:r>
-          </a:p>
-          <a:p>
-            <a:pPr lvl="1"/>
-            <a:r>
-              <a:rPr lang="en-US" sz="1800" dirty="0">
-                <a:latin typeface="Times New Roman" panose="02020603050405020304" pitchFamily="18" charset="0"/>
-                <a:cs typeface="Times New Roman" panose="02020603050405020304" pitchFamily="18" charset="0"/>
-              </a:rPr>
-              <a:t>Pros : Transparently implement binary translation</a:t>
-            </a:r>
-          </a:p>
-          <a:p>
-            <a:pPr lvl="1"/>
-            <a:r>
-              <a:rPr lang="en-US" sz="1800" dirty="0">
-                <a:latin typeface="Times New Roman" panose="02020603050405020304" pitchFamily="18" charset="0"/>
-                <a:cs typeface="Times New Roman" panose="02020603050405020304" pitchFamily="18" charset="0"/>
-              </a:rPr>
-              <a:t>Cons : Hard to implement</a:t>
-            </a:r>
-          </a:p>
-        </p:txBody>
-      </p:sp>
-      <p:sp>
-        <p:nvSpPr>
-          <p:cNvPr id="4" name="灯片编号占位符 1">
-            <a:extLst>
-              <a:ext uri="{FF2B5EF4-FFF2-40B4-BE49-F238E27FC236}">
-                <a16:creationId xmlns:a16="http://schemas.microsoft.com/office/drawing/2014/main" id="{2FEF5301-2C84-013F-5F50-7D65316DFEDE}"/>
-              </a:ext>
-            </a:extLst>
-          </p:cNvPr>
-          <p:cNvSpPr>
-            <a:spLocks noGrp="1"/>
-          </p:cNvSpPr>
-          <p:nvPr>
-            <p:ph type="sldNum" sz="quarter" idx="10"/>
-          </p:nvPr>
-        </p:nvSpPr>
-        <p:spPr>
-          <a:xfrm>
-            <a:off x="6831013" y="4893471"/>
-            <a:ext cx="2133600" cy="254794"/>
-          </a:xfrm>
-        </p:spPr>
-        <p:txBody>
-          <a:bodyPr/>
-          <a:lstStyle/>
-          <a:p>
-            <a:fld id="{D9B6BDF2-6896-4B98-8776-C18582F63BA5}" type="slidenum">
-              <a:rPr lang="zh-TW" altLang="en-US" smtClean="0"/>
-              <a:pPr/>
-              <a:t>20</a:t>
-            </a:fld>
-            <a:endParaRPr lang="zh-TW" altLang="en-US"/>
-          </a:p>
-        </p:txBody>
-      </p:sp>
-    </p:spTree>
-    <p:extLst>
-      <p:ext uri="{BB962C8B-B14F-4D97-AF65-F5344CB8AC3E}">
-        <p14:creationId xmlns:p14="http://schemas.microsoft.com/office/powerpoint/2010/main" val="1419940445"/>
-      </p:ext>
-    </p:extLst>
-  </p:cSld>
-  <p:clrMapOvr>
-    <a:masterClrMapping/>
-  </p:clrMapOvr>
-</p:sld>
-</file>
-
-<file path=ppt/slides/slide21.xml><?xml version="1.0" encoding="utf-8"?>
-<p:sld xmlns:a="http://schemas.openxmlformats.org/drawingml/2006/main" xmlns:r="http://schemas.openxmlformats.org/officeDocument/2006/relationships" xmlns:p="http://schemas.openxmlformats.org/presentationml/2006/main">
-  <p:cSld>
-    <p:spTree>
-      <p:nvGrpSpPr>
-        <p:cNvPr id="1" name=""/>
-        <p:cNvGrpSpPr/>
-        <p:nvPr/>
-      </p:nvGrpSpPr>
-      <p:grpSpPr>
-        <a:xfrm>
-          <a:off x="0" y="0"/>
-          <a:ext cx="0" cy="0"/>
-          <a:chOff x="0" y="0"/>
-          <a:chExt cx="0" cy="0"/>
-        </a:xfrm>
-      </p:grpSpPr>
-      <p:sp>
-        <p:nvSpPr>
-          <p:cNvPr id="2" name="Title 1"/>
-          <p:cNvSpPr>
-            <a:spLocks noGrp="1"/>
-          </p:cNvSpPr>
-          <p:nvPr>
-            <p:ph type="title"/>
-          </p:nvPr>
-        </p:nvSpPr>
-        <p:spPr>
-          <a:xfrm>
             <a:off x="964276" y="79474"/>
             <a:ext cx="7711414" cy="519113"/>
           </a:xfrm>
@@ -6882,7 +6827,7 @@
         </p:nvGrpSpPr>
         <p:grpSpPr>
           <a:xfrm>
-            <a:off x="2009099" y="2421608"/>
+            <a:off x="2009099" y="2370806"/>
             <a:ext cx="4821914" cy="2175330"/>
             <a:chOff x="2000250" y="2288078"/>
             <a:chExt cx="4997597" cy="2308860"/>
@@ -8121,7 +8066,7 @@
             <a:fld id="{D9B6BDF2-6896-4B98-8776-C18582F63BA5}" type="slidenum">
               <a:rPr lang="zh-TW" altLang="en-US" smtClean="0"/>
               <a:pPr/>
-              <a:t>21</a:t>
+              <a:t>20</a:t>
             </a:fld>
             <a:endParaRPr lang="zh-TW" altLang="en-US"/>
           </a:p>
@@ -8403,7 +8348,7 @@
 </p:sld>
 </file>
 
-<file path=ppt/slides/slide22.xml><?xml version="1.0" encoding="utf-8"?>
+<file path=ppt/slides/slide21.xml><?xml version="1.0" encoding="utf-8"?>
 <p:sld xmlns:a="http://schemas.openxmlformats.org/drawingml/2006/main" xmlns:r="http://schemas.openxmlformats.org/officeDocument/2006/relationships" xmlns:p="http://schemas.openxmlformats.org/presentationml/2006/main">
   <p:cSld>
     <p:spTree>
@@ -8432,8 +8377,8 @@
         </p:nvSpPr>
         <p:spPr>
           <a:xfrm>
-            <a:off x="517467" y="2906164"/>
-            <a:ext cx="5829300" cy="1021556"/>
+            <a:off x="517466" y="2906164"/>
+            <a:ext cx="6721533" cy="1021556"/>
           </a:xfrm>
         </p:spPr>
         <p:txBody>
@@ -8477,7 +8422,7 @@
             <a:fld id="{D9B6BDF2-6896-4B98-8776-C18582F63BA5}" type="slidenum">
               <a:rPr lang="zh-TW" altLang="en-US" smtClean="0"/>
               <a:pPr/>
-              <a:t>22</a:t>
+              <a:t>21</a:t>
             </a:fld>
             <a:endParaRPr lang="zh-TW" altLang="en-US"/>
           </a:p>
@@ -8496,7 +8441,7 @@
 </p:sld>
 </file>
 
-<file path=ppt/slides/slide23.xml><?xml version="1.0" encoding="utf-8"?>
+<file path=ppt/slides/slide22.xml><?xml version="1.0" encoding="utf-8"?>
 <p:sld xmlns:a="http://schemas.openxmlformats.org/drawingml/2006/main" xmlns:r="http://schemas.openxmlformats.org/officeDocument/2006/relationships" xmlns:p="http://schemas.openxmlformats.org/presentationml/2006/main">
   <p:cSld>
     <p:spTree>
@@ -8652,7 +8597,7 @@
             <a:fld id="{D9B6BDF2-6896-4B98-8776-C18582F63BA5}" type="slidenum">
               <a:rPr lang="zh-TW" altLang="en-US" smtClean="0"/>
               <a:pPr/>
-              <a:t>23</a:t>
+              <a:t>22</a:t>
             </a:fld>
             <a:endParaRPr lang="zh-TW" altLang="en-US"/>
           </a:p>
@@ -8662,6 +8607,153 @@
     <p:extLst>
       <p:ext uri="{BB962C8B-B14F-4D97-AF65-F5344CB8AC3E}">
         <p14:creationId xmlns:p14="http://schemas.microsoft.com/office/powerpoint/2010/main" val="4128967270"/>
+      </p:ext>
+    </p:extLst>
+  </p:cSld>
+  <p:clrMapOvr>
+    <a:masterClrMapping/>
+  </p:clrMapOvr>
+</p:sld>
+</file>
+
+<file path=ppt/slides/slide23.xml><?xml version="1.0" encoding="utf-8"?>
+<p:sld xmlns:a="http://schemas.openxmlformats.org/drawingml/2006/main" xmlns:r="http://schemas.openxmlformats.org/officeDocument/2006/relationships" xmlns:p="http://schemas.openxmlformats.org/presentationml/2006/main">
+  <p:cSld>
+    <p:spTree>
+      <p:nvGrpSpPr>
+        <p:cNvPr id="1" name=""/>
+        <p:cNvGrpSpPr/>
+        <p:nvPr/>
+      </p:nvGrpSpPr>
+      <p:grpSpPr>
+        <a:xfrm>
+          <a:off x="0" y="0"/>
+          <a:ext cx="0" cy="0"/>
+          <a:chOff x="0" y="0"/>
+          <a:chExt cx="0" cy="0"/>
+        </a:xfrm>
+      </p:grpSpPr>
+      <p:sp>
+        <p:nvSpPr>
+          <p:cNvPr id="2" name="Title 1"/>
+          <p:cNvSpPr>
+            <a:spLocks noGrp="1"/>
+          </p:cNvSpPr>
+          <p:nvPr>
+            <p:ph type="title"/>
+          </p:nvPr>
+        </p:nvSpPr>
+        <p:spPr>
+          <a:xfrm>
+            <a:off x="924026" y="79474"/>
+            <a:ext cx="7780540" cy="519113"/>
+          </a:xfrm>
+        </p:spPr>
+        <p:txBody>
+          <a:bodyPr/>
+          <a:lstStyle/>
+          <a:p>
+            <a:r>
+              <a:rPr lang="en-US" dirty="0"/>
+              <a:t>Register Mapping Problem (2)</a:t>
+            </a:r>
+          </a:p>
+        </p:txBody>
+      </p:sp>
+      <p:sp>
+        <p:nvSpPr>
+          <p:cNvPr id="3" name="Content Placeholder 2"/>
+          <p:cNvSpPr>
+            <a:spLocks noGrp="1"/>
+          </p:cNvSpPr>
+          <p:nvPr>
+            <p:ph idx="1"/>
+          </p:nvPr>
+        </p:nvSpPr>
+        <p:spPr>
+          <a:xfrm>
+            <a:off x="1024466" y="856365"/>
+            <a:ext cx="7513809" cy="2301701"/>
+          </a:xfrm>
+        </p:spPr>
+        <p:txBody>
+          <a:bodyPr/>
+          <a:lstStyle/>
+          <a:p>
+            <a:r>
+              <a:rPr lang="en-US" sz="2200" dirty="0"/>
+              <a:t>If the number of host registers is larger that those of the guest</a:t>
+            </a:r>
+          </a:p>
+          <a:p>
+            <a:pPr lvl="1"/>
+            <a:r>
+              <a:rPr lang="en-US" sz="2000" dirty="0"/>
+              <a:t>That will be an easier case for implementation</a:t>
+            </a:r>
+          </a:p>
+          <a:p>
+            <a:pPr lvl="1"/>
+            <a:r>
+              <a:rPr lang="en-US" sz="2000" dirty="0"/>
+              <a:t>Directly map one register of guest to one of host, and make use of the rest registers for optimization</a:t>
+            </a:r>
+          </a:p>
+          <a:p>
+            <a:pPr lvl="1"/>
+            <a:r>
+              <a:rPr lang="en-US" sz="2000" dirty="0"/>
+              <a:t>Example </a:t>
+            </a:r>
+          </a:p>
+          <a:p>
+            <a:pPr lvl="2"/>
+            <a:r>
+              <a:rPr lang="en-US" sz="1800" dirty="0"/>
+              <a:t>Translating RISC binary to x86</a:t>
+            </a:r>
+          </a:p>
+        </p:txBody>
+      </p:sp>
+      <p:sp>
+        <p:nvSpPr>
+          <p:cNvPr id="4" name="灯片编号占位符 1">
+            <a:extLst>
+              <a:ext uri="{FF2B5EF4-FFF2-40B4-BE49-F238E27FC236}">
+                <a16:creationId xmlns:a16="http://schemas.microsoft.com/office/drawing/2014/main" id="{6EF8F205-49B1-BC23-34E2-C02CCFAA463E}"/>
+              </a:ext>
+            </a:extLst>
+          </p:cNvPr>
+          <p:cNvSpPr>
+            <a:spLocks noGrp="1"/>
+          </p:cNvSpPr>
+          <p:nvPr>
+            <p:ph type="sldNum" sz="quarter" idx="10"/>
+          </p:nvPr>
+        </p:nvSpPr>
+        <p:spPr>
+          <a:xfrm>
+            <a:off x="6831013" y="4901784"/>
+            <a:ext cx="2133600" cy="254794"/>
+          </a:xfrm>
+        </p:spPr>
+        <p:txBody>
+          <a:bodyPr/>
+          <a:lstStyle/>
+          <a:p>
+            <a:fld id="{D9B6BDF2-6896-4B98-8776-C18582F63BA5}" type="slidenum">
+              <a:rPr lang="zh-TW" altLang="en-US" smtClean="0"/>
+              <a:pPr/>
+              <a:t>23</a:t>
+            </a:fld>
+            <a:endParaRPr lang="zh-TW" altLang="en-US"/>
+          </a:p>
+        </p:txBody>
+      </p:sp>
+    </p:spTree>
+    <p:extLst>
+      <p:ext uri="{BB962C8B-B14F-4D97-AF65-F5344CB8AC3E}">
+        <p14:creationId xmlns:p14="http://schemas.microsoft.com/office/powerpoint/2010/main" val="3745932253"/>
       </p:ext>
     </p:extLst>
   </p:cSld>
@@ -8700,8 +8792,8 @@
         </p:nvSpPr>
         <p:spPr>
           <a:xfrm>
-            <a:off x="924026" y="79474"/>
-            <a:ext cx="7780540" cy="519113"/>
+            <a:off x="897467" y="79474"/>
+            <a:ext cx="7778223" cy="519113"/>
           </a:xfrm>
         </p:spPr>
         <p:txBody>
@@ -8710,7 +8802,7 @@
           <a:p>
             <a:r>
               <a:rPr lang="en-US" dirty="0"/>
-              <a:t>Register Mapping Problem (2)</a:t>
+              <a:t>Register Mapping Problem (3)</a:t>
             </a:r>
           </a:p>
         </p:txBody>
@@ -8727,8 +8819,8 @@
         </p:nvSpPr>
         <p:spPr>
           <a:xfrm>
-            <a:off x="856211" y="856365"/>
-            <a:ext cx="7682065" cy="2301701"/>
+            <a:off x="964275" y="826855"/>
+            <a:ext cx="7124007" cy="2049347"/>
           </a:xfrm>
         </p:spPr>
         <p:txBody>
@@ -8736,36 +8828,29 @@
           <a:lstStyle/>
           <a:p>
             <a:r>
-              <a:rPr lang="en-US" sz="2200" dirty="0"/>
-              <a:t>If the number of host registers is larger that those of the guest</a:t>
+              <a:rPr lang="en-US" sz="2400" dirty="0"/>
+              <a:t>If number of host registers is not enough</a:t>
             </a:r>
           </a:p>
           <a:p>
             <a:pPr lvl="1"/>
             <a:r>
               <a:rPr lang="en-US" sz="2000" dirty="0"/>
-              <a:t>That will be an easier case for implementation</a:t>
+              <a:t>That should involve more effort.</a:t>
             </a:r>
           </a:p>
           <a:p>
             <a:pPr lvl="1"/>
             <a:r>
               <a:rPr lang="en-US" sz="2000" dirty="0"/>
-              <a:t>Directly map one register of guest to one of host, and make use of the rest registers for optimization</a:t>
+              <a:t>Emulator may only map some frequently used guest registers to host, and left the unmapped registers in memory.</a:t>
             </a:r>
           </a:p>
           <a:p>
             <a:pPr lvl="1"/>
             <a:r>
               <a:rPr lang="en-US" sz="2000" dirty="0"/>
-              <a:t>Example </a:t>
-            </a:r>
-          </a:p>
-          <a:p>
-            <a:pPr lvl="2"/>
-            <a:r>
-              <a:rPr lang="en-US" sz="1800" dirty="0"/>
-              <a:t>Translating RISC binary to x86</a:t>
+              <a:t>Mapping decision will be critical in this case.</a:t>
             </a:r>
           </a:p>
         </p:txBody>
@@ -8808,7 +8893,7 @@
     </p:spTree>
     <p:extLst>
       <p:ext uri="{BB962C8B-B14F-4D97-AF65-F5344CB8AC3E}">
-        <p14:creationId xmlns:p14="http://schemas.microsoft.com/office/powerpoint/2010/main" val="3745932253"/>
+        <p14:creationId xmlns:p14="http://schemas.microsoft.com/office/powerpoint/2010/main" val="2246532134"/>
       </p:ext>
     </p:extLst>
   </p:cSld>
@@ -8847,146 +8932,6 @@
         </p:nvSpPr>
         <p:spPr>
           <a:xfrm>
-            <a:off x="856211" y="79474"/>
-            <a:ext cx="7819479" cy="519113"/>
-          </a:xfrm>
-        </p:spPr>
-        <p:txBody>
-          <a:bodyPr/>
-          <a:lstStyle/>
-          <a:p>
-            <a:r>
-              <a:rPr lang="en-US" dirty="0"/>
-              <a:t>Register Mapping Problem (3)</a:t>
-            </a:r>
-          </a:p>
-        </p:txBody>
-      </p:sp>
-      <p:sp>
-        <p:nvSpPr>
-          <p:cNvPr id="3" name="Content Placeholder 2"/>
-          <p:cNvSpPr>
-            <a:spLocks noGrp="1"/>
-          </p:cNvSpPr>
-          <p:nvPr>
-            <p:ph idx="1"/>
-          </p:nvPr>
-        </p:nvSpPr>
-        <p:spPr>
-          <a:xfrm>
-            <a:off x="964275" y="826855"/>
-            <a:ext cx="7124007" cy="2049347"/>
-          </a:xfrm>
-        </p:spPr>
-        <p:txBody>
-          <a:bodyPr/>
-          <a:lstStyle/>
-          <a:p>
-            <a:r>
-              <a:rPr lang="en-US" sz="2400" dirty="0"/>
-              <a:t>If number of host registers is not enough</a:t>
-            </a:r>
-          </a:p>
-          <a:p>
-            <a:pPr lvl="1"/>
-            <a:r>
-              <a:rPr lang="en-US" sz="2000" dirty="0"/>
-              <a:t>That should involve more effort.</a:t>
-            </a:r>
-          </a:p>
-          <a:p>
-            <a:pPr lvl="1"/>
-            <a:r>
-              <a:rPr lang="en-US" sz="2000" dirty="0"/>
-              <a:t>Emulator may only map some frequently used guest registers to host, and left the unmapped registers in memory.</a:t>
-            </a:r>
-          </a:p>
-          <a:p>
-            <a:pPr lvl="1"/>
-            <a:r>
-              <a:rPr lang="en-US" sz="2000" dirty="0"/>
-              <a:t>Mapping decision will be critical in this case.</a:t>
-            </a:r>
-          </a:p>
-        </p:txBody>
-      </p:sp>
-      <p:sp>
-        <p:nvSpPr>
-          <p:cNvPr id="4" name="灯片编号占位符 1">
-            <a:extLst>
-              <a:ext uri="{FF2B5EF4-FFF2-40B4-BE49-F238E27FC236}">
-                <a16:creationId xmlns:a16="http://schemas.microsoft.com/office/drawing/2014/main" id="{6EF8F205-49B1-BC23-34E2-C02CCFAA463E}"/>
-              </a:ext>
-            </a:extLst>
-          </p:cNvPr>
-          <p:cNvSpPr>
-            <a:spLocks noGrp="1"/>
-          </p:cNvSpPr>
-          <p:nvPr>
-            <p:ph type="sldNum" sz="quarter" idx="10"/>
-          </p:nvPr>
-        </p:nvSpPr>
-        <p:spPr>
-          <a:xfrm>
-            <a:off x="6831013" y="4901784"/>
-            <a:ext cx="2133600" cy="254794"/>
-          </a:xfrm>
-        </p:spPr>
-        <p:txBody>
-          <a:bodyPr/>
-          <a:lstStyle/>
-          <a:p>
-            <a:fld id="{D9B6BDF2-6896-4B98-8776-C18582F63BA5}" type="slidenum">
-              <a:rPr lang="zh-TW" altLang="en-US" smtClean="0"/>
-              <a:pPr/>
-              <a:t>25</a:t>
-            </a:fld>
-            <a:endParaRPr lang="zh-TW" altLang="en-US"/>
-          </a:p>
-        </p:txBody>
-      </p:sp>
-    </p:spTree>
-    <p:extLst>
-      <p:ext uri="{BB962C8B-B14F-4D97-AF65-F5344CB8AC3E}">
-        <p14:creationId xmlns:p14="http://schemas.microsoft.com/office/powerpoint/2010/main" val="2246532134"/>
-      </p:ext>
-    </p:extLst>
-  </p:cSld>
-  <p:clrMapOvr>
-    <a:masterClrMapping/>
-  </p:clrMapOvr>
-</p:sld>
-</file>
-
-<file path=ppt/slides/slide26.xml><?xml version="1.0" encoding="utf-8"?>
-<p:sld xmlns:a="http://schemas.openxmlformats.org/drawingml/2006/main" xmlns:r="http://schemas.openxmlformats.org/officeDocument/2006/relationships" xmlns:p="http://schemas.openxmlformats.org/presentationml/2006/main">
-  <p:cSld>
-    <p:spTree>
-      <p:nvGrpSpPr>
-        <p:cNvPr id="1" name=""/>
-        <p:cNvGrpSpPr/>
-        <p:nvPr/>
-      </p:nvGrpSpPr>
-      <p:grpSpPr>
-        <a:xfrm>
-          <a:off x="0" y="0"/>
-          <a:ext cx="0" cy="0"/>
-          <a:chOff x="0" y="0"/>
-          <a:chExt cx="0" cy="0"/>
-        </a:xfrm>
-      </p:grpSpPr>
-      <p:sp>
-        <p:nvSpPr>
-          <p:cNvPr id="2" name="Title 1"/>
-          <p:cNvSpPr>
-            <a:spLocks noGrp="1"/>
-          </p:cNvSpPr>
-          <p:nvPr>
-            <p:ph type="title"/>
-          </p:nvPr>
-        </p:nvSpPr>
-        <p:spPr>
-          <a:xfrm>
             <a:off x="881149" y="79474"/>
             <a:ext cx="7794541" cy="519113"/>
           </a:xfrm>
@@ -9112,7 +9057,7 @@
             <a:fld id="{D9B6BDF2-6896-4B98-8776-C18582F63BA5}" type="slidenum">
               <a:rPr lang="zh-TW" altLang="en-US" smtClean="0"/>
               <a:pPr/>
-              <a:t>26</a:t>
+              <a:t>25</a:t>
             </a:fld>
             <a:endParaRPr lang="zh-TW" altLang="en-US"/>
           </a:p>
@@ -9131,7 +9076,7 @@
 </p:sld>
 </file>
 
-<file path=ppt/slides/slide27.xml><?xml version="1.0" encoding="utf-8"?>
+<file path=ppt/slides/slide26.xml><?xml version="1.0" encoding="utf-8"?>
 <p:sld xmlns:a="http://schemas.openxmlformats.org/drawingml/2006/main" xmlns:r="http://schemas.openxmlformats.org/officeDocument/2006/relationships" xmlns:p="http://schemas.openxmlformats.org/presentationml/2006/main">
   <p:cSld>
     <p:spTree>
@@ -9414,7 +9359,7 @@
             <a:fld id="{D9B6BDF2-6896-4B98-8776-C18582F63BA5}" type="slidenum">
               <a:rPr lang="zh-TW" altLang="en-US" smtClean="0"/>
               <a:pPr/>
-              <a:t>27</a:t>
+              <a:t>26</a:t>
             </a:fld>
             <a:endParaRPr lang="zh-TW" altLang="en-US"/>
           </a:p>
@@ -9555,7 +9500,7 @@
 </p:sld>
 </file>
 
-<file path=ppt/slides/slide28.xml><?xml version="1.0" encoding="utf-8"?>
+<file path=ppt/slides/slide27.xml><?xml version="1.0" encoding="utf-8"?>
 <p:sld xmlns:a="http://schemas.openxmlformats.org/drawingml/2006/main" xmlns:r="http://schemas.openxmlformats.org/officeDocument/2006/relationships" xmlns:p="http://schemas.openxmlformats.org/presentationml/2006/main">
   <p:cSld>
     <p:spTree>
@@ -9691,7 +9636,7 @@
             <a:fld id="{D9B6BDF2-6896-4B98-8776-C18582F63BA5}" type="slidenum">
               <a:rPr lang="zh-TW" altLang="en-US" smtClean="0"/>
               <a:pPr/>
-              <a:t>28</a:t>
+              <a:t>27</a:t>
             </a:fld>
             <a:endParaRPr lang="zh-TW" altLang="en-US"/>
           </a:p>
@@ -9701,6 +9646,185 @@
     <p:extLst>
       <p:ext uri="{BB962C8B-B14F-4D97-AF65-F5344CB8AC3E}">
         <p14:creationId xmlns:p14="http://schemas.microsoft.com/office/powerpoint/2010/main" val="1282063448"/>
+      </p:ext>
+    </p:extLst>
+  </p:cSld>
+  <p:clrMapOvr>
+    <a:masterClrMapping/>
+  </p:clrMapOvr>
+</p:sld>
+</file>
+
+<file path=ppt/slides/slide28.xml><?xml version="1.0" encoding="utf-8"?>
+<p:sld xmlns:a="http://schemas.openxmlformats.org/drawingml/2006/main" xmlns:r="http://schemas.openxmlformats.org/officeDocument/2006/relationships" xmlns:p="http://schemas.openxmlformats.org/presentationml/2006/main">
+  <p:cSld>
+    <p:spTree>
+      <p:nvGrpSpPr>
+        <p:cNvPr id="1" name=""/>
+        <p:cNvGrpSpPr/>
+        <p:nvPr/>
+      </p:nvGrpSpPr>
+      <p:grpSpPr>
+        <a:xfrm>
+          <a:off x="0" y="0"/>
+          <a:ext cx="0" cy="0"/>
+          <a:chOff x="0" y="0"/>
+          <a:chExt cx="0" cy="0"/>
+        </a:xfrm>
+      </p:grpSpPr>
+      <p:sp>
+        <p:nvSpPr>
+          <p:cNvPr id="2" name="Title 1"/>
+          <p:cNvSpPr>
+            <a:spLocks noGrp="1"/>
+          </p:cNvSpPr>
+          <p:nvPr>
+            <p:ph type="title"/>
+          </p:nvPr>
+        </p:nvSpPr>
+        <p:spPr>
+          <a:xfrm>
+            <a:off x="972588" y="79474"/>
+            <a:ext cx="7703102" cy="519113"/>
+          </a:xfrm>
+        </p:spPr>
+        <p:txBody>
+          <a:bodyPr/>
+          <a:lstStyle/>
+          <a:p>
+            <a:r>
+              <a:rPr lang="en-US" dirty="0"/>
+              <a:t>Dynamic Optimization (1)</a:t>
+            </a:r>
+          </a:p>
+        </p:txBody>
+      </p:sp>
+      <p:sp>
+        <p:nvSpPr>
+          <p:cNvPr id="3" name="Content Placeholder 2"/>
+          <p:cNvSpPr>
+            <a:spLocks noGrp="1"/>
+          </p:cNvSpPr>
+          <p:nvPr>
+            <p:ph idx="1"/>
+          </p:nvPr>
+        </p:nvSpPr>
+        <p:spPr>
+          <a:xfrm>
+            <a:off x="972588" y="822960"/>
+            <a:ext cx="7198823" cy="3075710"/>
+          </a:xfrm>
+        </p:spPr>
+        <p:txBody>
+          <a:bodyPr>
+            <a:noAutofit/>
+          </a:bodyPr>
+          <a:lstStyle/>
+          <a:p>
+            <a:r>
+              <a:rPr lang="en-US" sz="2400" dirty="0">
+                <a:latin typeface="Times New Roman" panose="02020603050405020304" pitchFamily="18" charset="0"/>
+                <a:cs typeface="Times New Roman" panose="02020603050405020304" pitchFamily="18" charset="0"/>
+              </a:rPr>
+              <a:t>How to optimize binary codes ?</a:t>
+            </a:r>
+          </a:p>
+          <a:p>
+            <a:pPr lvl="1"/>
+            <a:r>
+              <a:rPr lang="en-US" sz="2200" dirty="0">
+                <a:latin typeface="Times New Roman" panose="02020603050405020304" pitchFamily="18" charset="0"/>
+                <a:cs typeface="Times New Roman" panose="02020603050405020304" pitchFamily="18" charset="0"/>
+              </a:rPr>
+              <a:t>Static optimization (compiling time optimization)</a:t>
+            </a:r>
+          </a:p>
+          <a:p>
+            <a:pPr lvl="2"/>
+            <a:r>
+              <a:rPr lang="en-US" dirty="0">
+                <a:latin typeface="Times New Roman" panose="02020603050405020304" pitchFamily="18" charset="0"/>
+                <a:cs typeface="Times New Roman" panose="02020603050405020304" pitchFamily="18" charset="0"/>
+              </a:rPr>
+              <a:t>Optimization techniques apply to generate binary code base on the </a:t>
+            </a:r>
+            <a:r>
+              <a:rPr lang="en-US" altLang="zh-TW" dirty="0">
+                <a:latin typeface="Times New Roman" panose="02020603050405020304" pitchFamily="18" charset="0"/>
+                <a:ea typeface="新細明體" charset="-120"/>
+                <a:cs typeface="Times New Roman" panose="02020603050405020304" pitchFamily="18" charset="0"/>
+              </a:rPr>
+              <a:t>semantic </a:t>
+            </a:r>
+            <a:r>
+              <a:rPr lang="en-US" dirty="0">
+                <a:latin typeface="Times New Roman" panose="02020603050405020304" pitchFamily="18" charset="0"/>
+                <a:cs typeface="Times New Roman" panose="02020603050405020304" pitchFamily="18" charset="0"/>
+              </a:rPr>
+              <a:t>information in source code.</a:t>
+            </a:r>
+          </a:p>
+          <a:p>
+            <a:pPr lvl="1"/>
+            <a:r>
+              <a:rPr lang="en-US" sz="2200" dirty="0">
+                <a:latin typeface="Times New Roman" panose="02020603050405020304" pitchFamily="18" charset="0"/>
+                <a:cs typeface="Times New Roman" panose="02020603050405020304" pitchFamily="18" charset="0"/>
+              </a:rPr>
+              <a:t>Dynamic optimization (run time optimization)</a:t>
+            </a:r>
+          </a:p>
+          <a:p>
+            <a:pPr lvl="2"/>
+            <a:r>
+              <a:rPr lang="en-US" dirty="0">
+                <a:latin typeface="Times New Roman" panose="02020603050405020304" pitchFamily="18" charset="0"/>
+                <a:cs typeface="Times New Roman" panose="02020603050405020304" pitchFamily="18" charset="0"/>
+              </a:rPr>
+              <a:t>Optimization techniques apply to generated binary code base on the run time information which relate to program input data.</a:t>
+            </a:r>
+          </a:p>
+        </p:txBody>
+      </p:sp>
+      <p:sp>
+        <p:nvSpPr>
+          <p:cNvPr id="4" name="灯片编号占位符 1">
+            <a:extLst>
+              <a:ext uri="{FF2B5EF4-FFF2-40B4-BE49-F238E27FC236}">
+                <a16:creationId xmlns:a16="http://schemas.microsoft.com/office/drawing/2014/main" id="{B65FC22E-2DB0-A7FA-04F5-109E44407D6F}"/>
+              </a:ext>
+            </a:extLst>
+          </p:cNvPr>
+          <p:cNvSpPr>
+            <a:spLocks noGrp="1"/>
+          </p:cNvSpPr>
+          <p:nvPr>
+            <p:ph type="sldNum" sz="quarter" idx="10"/>
+          </p:nvPr>
+        </p:nvSpPr>
+        <p:spPr>
+          <a:xfrm>
+            <a:off x="6831013" y="4893471"/>
+            <a:ext cx="2133600" cy="254794"/>
+          </a:xfrm>
+        </p:spPr>
+        <p:txBody>
+          <a:bodyPr/>
+          <a:lstStyle/>
+          <a:p>
+            <a:fld id="{D9B6BDF2-6896-4B98-8776-C18582F63BA5}" type="slidenum">
+              <a:rPr lang="zh-TW" altLang="en-US" smtClean="0"/>
+              <a:pPr/>
+              <a:t>28</a:t>
+            </a:fld>
+            <a:endParaRPr lang="zh-TW" altLang="en-US"/>
+          </a:p>
+        </p:txBody>
+      </p:sp>
+    </p:spTree>
+    <p:extLst>
+      <p:ext uri="{BB962C8B-B14F-4D97-AF65-F5344CB8AC3E}">
+        <p14:creationId xmlns:p14="http://schemas.microsoft.com/office/powerpoint/2010/main" val="1803497324"/>
       </p:ext>
     </p:extLst>
   </p:cSld>
@@ -9739,8 +9863,8 @@
         </p:nvSpPr>
         <p:spPr>
           <a:xfrm>
-            <a:off x="972588" y="79474"/>
-            <a:ext cx="7703102" cy="519113"/>
+            <a:off x="972152" y="79474"/>
+            <a:ext cx="7703538" cy="519113"/>
           </a:xfrm>
         </p:spPr>
         <p:txBody>
@@ -9749,7 +9873,7 @@
           <a:p>
             <a:r>
               <a:rPr lang="en-US" dirty="0"/>
-              <a:t>Dynamic Optimization (1)</a:t>
+              <a:t>Dynamic Optimization (2)</a:t>
             </a:r>
           </a:p>
         </p:txBody>
@@ -9766,8 +9890,8 @@
         </p:nvSpPr>
         <p:spPr>
           <a:xfrm>
-            <a:off x="972588" y="822960"/>
-            <a:ext cx="7198823" cy="3075710"/>
+            <a:off x="972152" y="822962"/>
+            <a:ext cx="7149383" cy="2128059"/>
           </a:xfrm>
         </p:spPr>
         <p:txBody>
@@ -9781,7 +9905,7 @@
                 <a:latin typeface="Times New Roman" panose="02020603050405020304" pitchFamily="18" charset="0"/>
                 <a:cs typeface="Times New Roman" panose="02020603050405020304" pitchFamily="18" charset="0"/>
               </a:rPr>
-              <a:t>How to optimize binary codes ?</a:t>
+              <a:t>Why we use dynamic optimization technique ?</a:t>
             </a:r>
           </a:p>
           <a:p>
@@ -9791,7 +9915,7 @@
                 <a:latin typeface="Times New Roman" panose="02020603050405020304" pitchFamily="18" charset="0"/>
                 <a:cs typeface="Times New Roman" panose="02020603050405020304" pitchFamily="18" charset="0"/>
               </a:rPr>
-              <a:t>Static optimization (compiling time optimization)</a:t>
+              <a:t>Advantages </a:t>
             </a:r>
           </a:p>
           <a:p>
@@ -9801,32 +9925,17 @@
                 <a:latin typeface="Times New Roman" panose="02020603050405020304" pitchFamily="18" charset="0"/>
                 <a:cs typeface="Times New Roman" panose="02020603050405020304" pitchFamily="18" charset="0"/>
               </a:rPr>
-              <a:t>Optimization techniques apply to generate binary code base on the </a:t>
-            </a:r>
-            <a:r>
-              <a:rPr lang="en-US" altLang="zh-TW" dirty="0">
-                <a:latin typeface="Times New Roman" panose="02020603050405020304" pitchFamily="18" charset="0"/>
-                <a:ea typeface="新細明體" charset="-120"/>
-                <a:cs typeface="Times New Roman" panose="02020603050405020304" pitchFamily="18" charset="0"/>
-              </a:rPr>
-              <a:t>semantic </a:t>
-            </a:r>
+              <a:t>It  can benefit from dynamic profiling.</a:t>
+            </a:r>
+          </a:p>
+          <a:p>
+            <a:pPr lvl="2"/>
             <a:r>
               <a:rPr lang="en-US" dirty="0">
                 <a:latin typeface="Times New Roman" panose="02020603050405020304" pitchFamily="18" charset="0"/>
                 <a:cs typeface="Times New Roman" panose="02020603050405020304" pitchFamily="18" charset="0"/>
               </a:rPr>
-              <a:t>information in source code.</a:t>
-            </a:r>
-          </a:p>
-          <a:p>
-            <a:pPr lvl="1"/>
-            <a:r>
-              <a:rPr lang="en-US" sz="2200" dirty="0">
-                <a:latin typeface="Times New Roman" panose="02020603050405020304" pitchFamily="18" charset="0"/>
-                <a:cs typeface="Times New Roman" panose="02020603050405020304" pitchFamily="18" charset="0"/>
-              </a:rPr>
-              <a:t>Dynamic optimization (run time optimization)</a:t>
+              <a:t>It is not constrained by a compilation unit.</a:t>
             </a:r>
           </a:p>
           <a:p>
@@ -9836,7 +9945,7 @@
                 <a:latin typeface="Times New Roman" panose="02020603050405020304" pitchFamily="18" charset="0"/>
                 <a:cs typeface="Times New Roman" panose="02020603050405020304" pitchFamily="18" charset="0"/>
               </a:rPr>
-              <a:t>Optimization techniques apply to generated binary code base on the run time information which relate to program input data.</a:t>
+              <a:t>It  knows the exact execution environment.</a:t>
             </a:r>
           </a:p>
         </p:txBody>
@@ -9879,7 +9988,7 @@
     </p:spTree>
     <p:extLst>
       <p:ext uri="{BB962C8B-B14F-4D97-AF65-F5344CB8AC3E}">
-        <p14:creationId xmlns:p14="http://schemas.microsoft.com/office/powerpoint/2010/main" val="1803497324"/>
+        <p14:creationId xmlns:p14="http://schemas.microsoft.com/office/powerpoint/2010/main" val="971238768"/>
       </p:ext>
     </p:extLst>
   </p:cSld>
@@ -9990,8 +10099,8 @@
         </p:nvSpPr>
         <p:spPr>
           <a:xfrm>
-            <a:off x="972152" y="79474"/>
-            <a:ext cx="7703538" cy="519113"/>
+            <a:off x="914400" y="79474"/>
+            <a:ext cx="7761290" cy="519113"/>
           </a:xfrm>
         </p:spPr>
         <p:txBody>
@@ -10000,7 +10109,7 @@
           <a:p>
             <a:r>
               <a:rPr lang="en-US" dirty="0"/>
-              <a:t>Dynamic Optimization (2)</a:t>
+              <a:t>Dynamic Optimization (3)</a:t>
             </a:r>
           </a:p>
         </p:txBody>
@@ -10017,14 +10126,12 @@
         </p:nvSpPr>
         <p:spPr>
           <a:xfrm>
-            <a:off x="897774" y="822962"/>
-            <a:ext cx="7223761" cy="2128059"/>
+            <a:off x="914400" y="844153"/>
+            <a:ext cx="7456516" cy="3254022"/>
           </a:xfrm>
         </p:spPr>
         <p:txBody>
-          <a:bodyPr>
-            <a:noAutofit/>
-          </a:bodyPr>
+          <a:bodyPr/>
           <a:lstStyle/>
           <a:p>
             <a:r>
@@ -10032,47 +10139,47 @@
                 <a:latin typeface="Times New Roman" panose="02020603050405020304" pitchFamily="18" charset="0"/>
                 <a:cs typeface="Times New Roman" panose="02020603050405020304" pitchFamily="18" charset="0"/>
               </a:rPr>
-              <a:t>Why we use dynamic optimization technique ?</a:t>
+              <a:t>How to implement dynamic optimization </a:t>
             </a:r>
           </a:p>
           <a:p>
             <a:pPr lvl="1"/>
             <a:r>
-              <a:rPr lang="en-US" sz="2200" dirty="0">
-                <a:latin typeface="Times New Roman" panose="02020603050405020304" pitchFamily="18" charset="0"/>
-                <a:cs typeface="Times New Roman" panose="02020603050405020304" pitchFamily="18" charset="0"/>
-              </a:rPr>
-              <a:t>Advantages </a:t>
-            </a:r>
-          </a:p>
-          <a:p>
-            <a:pPr lvl="2"/>
-            <a:r>
-              <a:rPr lang="en-US" dirty="0">
-                <a:latin typeface="Times New Roman" panose="02020603050405020304" pitchFamily="18" charset="0"/>
-                <a:cs typeface="Times New Roman" panose="02020603050405020304" pitchFamily="18" charset="0"/>
-              </a:rPr>
-              <a:t>It  can benefit from dynamic profiling.</a:t>
-            </a:r>
-          </a:p>
-          <a:p>
-            <a:pPr lvl="2"/>
-            <a:r>
-              <a:rPr lang="en-US" dirty="0">
-                <a:latin typeface="Times New Roman" panose="02020603050405020304" pitchFamily="18" charset="0"/>
-                <a:cs typeface="Times New Roman" panose="02020603050405020304" pitchFamily="18" charset="0"/>
-              </a:rPr>
-              <a:t>It is not constrained by a compilation unit.</a:t>
-            </a:r>
-          </a:p>
-          <a:p>
-            <a:pPr lvl="2"/>
-            <a:r>
-              <a:rPr lang="en-US" dirty="0">
-                <a:latin typeface="Times New Roman" panose="02020603050405020304" pitchFamily="18" charset="0"/>
-                <a:cs typeface="Times New Roman" panose="02020603050405020304" pitchFamily="18" charset="0"/>
-              </a:rPr>
-              <a:t>It  knows the exact execution environment.</a:t>
+              <a:rPr lang="en-US" sz="2000" dirty="0">
+                <a:latin typeface="Times New Roman" panose="02020603050405020304" pitchFamily="18" charset="0"/>
+                <a:cs typeface="Times New Roman" panose="02020603050405020304" pitchFamily="18" charset="0"/>
+              </a:rPr>
+              <a:t>Analysis program behavior in run time</a:t>
+            </a:r>
+          </a:p>
+          <a:p>
+            <a:pPr lvl="1"/>
+            <a:r>
+              <a:rPr lang="en-US" sz="2000" dirty="0">
+                <a:latin typeface="Times New Roman" panose="02020603050405020304" pitchFamily="18" charset="0"/>
+                <a:cs typeface="Times New Roman" panose="02020603050405020304" pitchFamily="18" charset="0"/>
+              </a:rPr>
+              <a:t>Collect run time profiling information based on the input data and host hardware characteristics</a:t>
+            </a:r>
+          </a:p>
+          <a:p>
+            <a:pPr lvl="1"/>
+            <a:r>
+              <a:rPr lang="en-US" sz="2000" dirty="0">
+                <a:latin typeface="Times New Roman" panose="02020603050405020304" pitchFamily="18" charset="0"/>
+                <a:cs typeface="Times New Roman" panose="02020603050405020304" pitchFamily="18" charset="0"/>
+              </a:rPr>
+              <a:t>Dynamically translate or modify the binary code by reordering instructions or other techniques</a:t>
+            </a:r>
+          </a:p>
+          <a:p>
+            <a:pPr lvl="1"/>
+            <a:r>
+              <a:rPr lang="en-US" sz="2000" dirty="0">
+                <a:latin typeface="Times New Roman" panose="02020603050405020304" pitchFamily="18" charset="0"/>
+                <a:cs typeface="Times New Roman" panose="02020603050405020304" pitchFamily="18" charset="0"/>
+              </a:rPr>
+              <a:t>Write back the optimized binary into code cache for next execution</a:t>
             </a:r>
           </a:p>
         </p:txBody>
@@ -10082,7 +10189,7 @@
           <p:cNvPr id="4" name="灯片编号占位符 1">
             <a:extLst>
               <a:ext uri="{FF2B5EF4-FFF2-40B4-BE49-F238E27FC236}">
-                <a16:creationId xmlns:a16="http://schemas.microsoft.com/office/drawing/2014/main" id="{B65FC22E-2DB0-A7FA-04F5-109E44407D6F}"/>
+                <a16:creationId xmlns:a16="http://schemas.microsoft.com/office/drawing/2014/main" id="{B6D35298-7189-589F-E56F-749EAC4913CE}"/>
               </a:ext>
             </a:extLst>
           </p:cNvPr>
@@ -10115,7 +10222,7 @@
     </p:spTree>
     <p:extLst>
       <p:ext uri="{BB962C8B-B14F-4D97-AF65-F5344CB8AC3E}">
-        <p14:creationId xmlns:p14="http://schemas.microsoft.com/office/powerpoint/2010/main" val="971238768"/>
+        <p14:creationId xmlns:p14="http://schemas.microsoft.com/office/powerpoint/2010/main" val="1711723878"/>
       </p:ext>
     </p:extLst>
   </p:cSld>
@@ -10164,168 +10271,6 @@
           <a:p>
             <a:r>
               <a:rPr lang="en-US" dirty="0"/>
-              <a:t>Dynamic Optimization (3)</a:t>
-            </a:r>
-          </a:p>
-        </p:txBody>
-      </p:sp>
-      <p:sp>
-        <p:nvSpPr>
-          <p:cNvPr id="3" name="Content Placeholder 2"/>
-          <p:cNvSpPr>
-            <a:spLocks noGrp="1"/>
-          </p:cNvSpPr>
-          <p:nvPr>
-            <p:ph idx="1"/>
-          </p:nvPr>
-        </p:nvSpPr>
-        <p:spPr>
-          <a:xfrm>
-            <a:off x="914400" y="844153"/>
-            <a:ext cx="7456516" cy="3254022"/>
-          </a:xfrm>
-        </p:spPr>
-        <p:txBody>
-          <a:bodyPr/>
-          <a:lstStyle/>
-          <a:p>
-            <a:r>
-              <a:rPr lang="en-US" dirty="0">
-                <a:latin typeface="Times New Roman" panose="02020603050405020304" pitchFamily="18" charset="0"/>
-                <a:cs typeface="Times New Roman" panose="02020603050405020304" pitchFamily="18" charset="0"/>
-              </a:rPr>
-              <a:t>How to implement dynamic optimization </a:t>
-            </a:r>
-          </a:p>
-          <a:p>
-            <a:pPr lvl="1"/>
-            <a:r>
-              <a:rPr lang="en-US" sz="2000" dirty="0">
-                <a:latin typeface="Times New Roman" panose="02020603050405020304" pitchFamily="18" charset="0"/>
-                <a:cs typeface="Times New Roman" panose="02020603050405020304" pitchFamily="18" charset="0"/>
-              </a:rPr>
-              <a:t>Analysis program behavior in run time</a:t>
-            </a:r>
-          </a:p>
-          <a:p>
-            <a:pPr lvl="1"/>
-            <a:r>
-              <a:rPr lang="en-US" sz="2000" dirty="0">
-                <a:latin typeface="Times New Roman" panose="02020603050405020304" pitchFamily="18" charset="0"/>
-                <a:cs typeface="Times New Roman" panose="02020603050405020304" pitchFamily="18" charset="0"/>
-              </a:rPr>
-              <a:t>Collect run time profiling information based on the input data and host hardware characteristics</a:t>
-            </a:r>
-          </a:p>
-          <a:p>
-            <a:pPr lvl="1"/>
-            <a:r>
-              <a:rPr lang="en-US" sz="2000" dirty="0">
-                <a:latin typeface="Times New Roman" panose="02020603050405020304" pitchFamily="18" charset="0"/>
-                <a:cs typeface="Times New Roman" panose="02020603050405020304" pitchFamily="18" charset="0"/>
-              </a:rPr>
-              <a:t>Dynamically translate or modify the binary code by reordering instructions or other techniques</a:t>
-            </a:r>
-          </a:p>
-          <a:p>
-            <a:pPr lvl="1"/>
-            <a:r>
-              <a:rPr lang="en-US" sz="2000" dirty="0">
-                <a:latin typeface="Times New Roman" panose="02020603050405020304" pitchFamily="18" charset="0"/>
-                <a:cs typeface="Times New Roman" panose="02020603050405020304" pitchFamily="18" charset="0"/>
-              </a:rPr>
-              <a:t>Write back the optimized binary into code cache for next execution</a:t>
-            </a:r>
-          </a:p>
-        </p:txBody>
-      </p:sp>
-      <p:sp>
-        <p:nvSpPr>
-          <p:cNvPr id="4" name="灯片编号占位符 1">
-            <a:extLst>
-              <a:ext uri="{FF2B5EF4-FFF2-40B4-BE49-F238E27FC236}">
-                <a16:creationId xmlns:a16="http://schemas.microsoft.com/office/drawing/2014/main" id="{B6D35298-7189-589F-E56F-749EAC4913CE}"/>
-              </a:ext>
-            </a:extLst>
-          </p:cNvPr>
-          <p:cNvSpPr>
-            <a:spLocks noGrp="1"/>
-          </p:cNvSpPr>
-          <p:nvPr>
-            <p:ph type="sldNum" sz="quarter" idx="10"/>
-          </p:nvPr>
-        </p:nvSpPr>
-        <p:spPr>
-          <a:xfrm>
-            <a:off x="6831013" y="4893471"/>
-            <a:ext cx="2133600" cy="254794"/>
-          </a:xfrm>
-        </p:spPr>
-        <p:txBody>
-          <a:bodyPr/>
-          <a:lstStyle/>
-          <a:p>
-            <a:fld id="{D9B6BDF2-6896-4B98-8776-C18582F63BA5}" type="slidenum">
-              <a:rPr lang="zh-TW" altLang="en-US" smtClean="0"/>
-              <a:pPr/>
-              <a:t>31</a:t>
-            </a:fld>
-            <a:endParaRPr lang="zh-TW" altLang="en-US"/>
-          </a:p>
-        </p:txBody>
-      </p:sp>
-    </p:spTree>
-    <p:extLst>
-      <p:ext uri="{BB962C8B-B14F-4D97-AF65-F5344CB8AC3E}">
-        <p14:creationId xmlns:p14="http://schemas.microsoft.com/office/powerpoint/2010/main" val="1711723878"/>
-      </p:ext>
-    </p:extLst>
-  </p:cSld>
-  <p:clrMapOvr>
-    <a:masterClrMapping/>
-  </p:clrMapOvr>
-</p:sld>
-</file>
-
-<file path=ppt/slides/slide32.xml><?xml version="1.0" encoding="utf-8"?>
-<p:sld xmlns:a="http://schemas.openxmlformats.org/drawingml/2006/main" xmlns:r="http://schemas.openxmlformats.org/officeDocument/2006/relationships" xmlns:p="http://schemas.openxmlformats.org/presentationml/2006/main">
-  <p:cSld>
-    <p:spTree>
-      <p:nvGrpSpPr>
-        <p:cNvPr id="1" name=""/>
-        <p:cNvGrpSpPr/>
-        <p:nvPr/>
-      </p:nvGrpSpPr>
-      <p:grpSpPr>
-        <a:xfrm>
-          <a:off x="0" y="0"/>
-          <a:ext cx="0" cy="0"/>
-          <a:chOff x="0" y="0"/>
-          <a:chExt cx="0" cy="0"/>
-        </a:xfrm>
-      </p:grpSpPr>
-      <p:sp>
-        <p:nvSpPr>
-          <p:cNvPr id="2" name="Title 1"/>
-          <p:cNvSpPr>
-            <a:spLocks noGrp="1"/>
-          </p:cNvSpPr>
-          <p:nvPr>
-            <p:ph type="title"/>
-          </p:nvPr>
-        </p:nvSpPr>
-        <p:spPr>
-          <a:xfrm>
-            <a:off x="914400" y="79474"/>
-            <a:ext cx="7761290" cy="519113"/>
-          </a:xfrm>
-        </p:spPr>
-        <p:txBody>
-          <a:bodyPr/>
-          <a:lstStyle/>
-          <a:p>
-            <a:r>
-              <a:rPr lang="en-US" dirty="0"/>
               <a:t>Dynamic Optimization (4)</a:t>
             </a:r>
           </a:p>
@@ -10459,7 +10404,7 @@
             <a:fld id="{D9B6BDF2-6896-4B98-8776-C18582F63BA5}" type="slidenum">
               <a:rPr lang="zh-TW" altLang="en-US" smtClean="0"/>
               <a:pPr/>
-              <a:t>32</a:t>
+              <a:t>31</a:t>
             </a:fld>
             <a:endParaRPr lang="zh-TW" altLang="en-US"/>
           </a:p>
@@ -10478,7 +10423,7 @@
 </p:sld>
 </file>
 
-<file path=ppt/slides/slide33.xml><?xml version="1.0" encoding="utf-8"?>
+<file path=ppt/slides/slide32.xml><?xml version="1.0" encoding="utf-8"?>
 <p:sld xmlns:a="http://schemas.openxmlformats.org/drawingml/2006/main" xmlns:r="http://schemas.openxmlformats.org/officeDocument/2006/relationships" xmlns:p="http://schemas.openxmlformats.org/presentationml/2006/main">
   <p:cSld>
     <p:spTree>
@@ -10663,7 +10608,7 @@
             <a:fld id="{D9B6BDF2-6896-4B98-8776-C18582F63BA5}" type="slidenum">
               <a:rPr lang="zh-TW" altLang="en-US" smtClean="0"/>
               <a:pPr/>
-              <a:t>33</a:t>
+              <a:t>32</a:t>
             </a:fld>
             <a:endParaRPr lang="zh-TW" altLang="en-US"/>
           </a:p>
@@ -10784,7 +10729,7 @@
 </p:sld>
 </file>
 
-<file path=ppt/slides/slide34.xml><?xml version="1.0" encoding="utf-8"?>
+<file path=ppt/slides/slide33.xml><?xml version="1.0" encoding="utf-8"?>
 <p:sld xmlns:a="http://schemas.openxmlformats.org/drawingml/2006/main" xmlns:r="http://schemas.openxmlformats.org/officeDocument/2006/relationships" xmlns:p="http://schemas.openxmlformats.org/presentationml/2006/main">
   <p:cSld>
     <p:spTree>
@@ -10856,7 +10801,7 @@
 </p:sld>
 </file>
 
-<file path=ppt/slides/slide35.xml><?xml version="1.0" encoding="utf-8"?>
+<file path=ppt/slides/slide34.xml><?xml version="1.0" encoding="utf-8"?>
 <p:sld xmlns:a="http://schemas.openxmlformats.org/drawingml/2006/main" xmlns:r="http://schemas.openxmlformats.org/officeDocument/2006/relationships" xmlns:p="http://schemas.openxmlformats.org/presentationml/2006/main">
   <p:cSld>
     <p:spTree>
@@ -11844,7 +11789,7 @@
             <a:fld id="{D9B6BDF2-6896-4B98-8776-C18582F63BA5}" type="slidenum">
               <a:rPr lang="zh-TW" altLang="en-US" smtClean="0"/>
               <a:pPr/>
-              <a:t>35</a:t>
+              <a:t>34</a:t>
             </a:fld>
             <a:endParaRPr lang="zh-TW" altLang="en-US"/>
           </a:p>
@@ -11863,7 +11808,7 @@
 </p:sld>
 </file>
 
-<file path=ppt/slides/slide36.xml><?xml version="1.0" encoding="utf-8"?>
+<file path=ppt/slides/slide35.xml><?xml version="1.0" encoding="utf-8"?>
 <p:sld xmlns:a="http://schemas.openxmlformats.org/drawingml/2006/main" xmlns:r="http://schemas.openxmlformats.org/officeDocument/2006/relationships" xmlns:p="http://schemas.openxmlformats.org/presentationml/2006/main">
   <p:cSld>
     <p:spTree>
@@ -12098,7 +12043,7 @@
             <a:fld id="{D9B6BDF2-6896-4B98-8776-C18582F63BA5}" type="slidenum">
               <a:rPr lang="zh-TW" altLang="en-US" smtClean="0"/>
               <a:pPr/>
-              <a:t>36</a:t>
+              <a:t>35</a:t>
             </a:fld>
             <a:endParaRPr lang="zh-TW" altLang="en-US"/>
           </a:p>
@@ -12117,7 +12062,7 @@
 </p:sld>
 </file>
 
-<file path=ppt/slides/slide37.xml><?xml version="1.0" encoding="utf-8"?>
+<file path=ppt/slides/slide36.xml><?xml version="1.0" encoding="utf-8"?>
 <p:sld xmlns:a="http://schemas.openxmlformats.org/drawingml/2006/main" xmlns:r="http://schemas.openxmlformats.org/officeDocument/2006/relationships" xmlns:p="http://schemas.openxmlformats.org/presentationml/2006/main">
   <p:cSld>
     <p:spTree>
@@ -12406,7 +12351,7 @@
             <a:fld id="{D9B6BDF2-6896-4B98-8776-C18582F63BA5}" type="slidenum">
               <a:rPr lang="zh-TW" altLang="en-US" smtClean="0"/>
               <a:pPr/>
-              <a:t>37</a:t>
+              <a:t>36</a:t>
             </a:fld>
             <a:endParaRPr lang="zh-TW" altLang="en-US"/>
           </a:p>
@@ -12425,7 +12370,7 @@
 </p:sld>
 </file>
 
-<file path=ppt/slides/slide38.xml><?xml version="1.0" encoding="utf-8"?>
+<file path=ppt/slides/slide37.xml><?xml version="1.0" encoding="utf-8"?>
 <p:sld xmlns:a="http://schemas.openxmlformats.org/drawingml/2006/main" xmlns:r="http://schemas.openxmlformats.org/officeDocument/2006/relationships" xmlns:p="http://schemas.openxmlformats.org/presentationml/2006/main">
   <p:cSld>
     <p:spTree>
@@ -12542,7 +12487,7 @@
             <a:fld id="{D9B6BDF2-6896-4B98-8776-C18582F63BA5}" type="slidenum">
               <a:rPr lang="zh-TW" altLang="en-US" smtClean="0"/>
               <a:pPr/>
-              <a:t>38</a:t>
+              <a:t>37</a:t>
             </a:fld>
             <a:endParaRPr lang="zh-TW" altLang="en-US"/>
           </a:p>
@@ -12552,6 +12497,271 @@
     <p:extLst>
       <p:ext uri="{BB962C8B-B14F-4D97-AF65-F5344CB8AC3E}">
         <p14:creationId xmlns:p14="http://schemas.microsoft.com/office/powerpoint/2010/main" val="3549340686"/>
+      </p:ext>
+    </p:extLst>
+  </p:cSld>
+  <p:clrMapOvr>
+    <a:masterClrMapping/>
+  </p:clrMapOvr>
+</p:sld>
+</file>
+
+<file path=ppt/slides/slide38.xml><?xml version="1.0" encoding="utf-8"?>
+<p:sld xmlns:a="http://schemas.openxmlformats.org/drawingml/2006/main" xmlns:r="http://schemas.openxmlformats.org/officeDocument/2006/relationships" xmlns:p="http://schemas.openxmlformats.org/presentationml/2006/main">
+  <p:cSld>
+    <p:spTree>
+      <p:nvGrpSpPr>
+        <p:cNvPr id="1" name=""/>
+        <p:cNvGrpSpPr/>
+        <p:nvPr/>
+      </p:nvGrpSpPr>
+      <p:grpSpPr>
+        <a:xfrm>
+          <a:off x="0" y="0"/>
+          <a:ext cx="0" cy="0"/>
+          <a:chOff x="0" y="0"/>
+          <a:chExt cx="0" cy="0"/>
+        </a:xfrm>
+      </p:grpSpPr>
+      <p:sp>
+        <p:nvSpPr>
+          <p:cNvPr id="4" name="標題 3"/>
+          <p:cNvSpPr>
+            <a:spLocks noGrp="1"/>
+          </p:cNvSpPr>
+          <p:nvPr>
+            <p:ph type="title"/>
+          </p:nvPr>
+        </p:nvSpPr>
+        <p:spPr>
+          <a:xfrm>
+            <a:off x="946610" y="79474"/>
+            <a:ext cx="7729079" cy="519113"/>
+          </a:xfrm>
+        </p:spPr>
+        <p:txBody>
+          <a:bodyPr/>
+          <a:lstStyle/>
+          <a:p>
+            <a:r>
+              <a:rPr kumimoji="1" lang="en-US" altLang="zh-TW" dirty="0"/>
+              <a:t>Full-Virtualization</a:t>
+            </a:r>
+            <a:endParaRPr kumimoji="1" lang="zh-TW" altLang="en-US" dirty="0"/>
+          </a:p>
+        </p:txBody>
+      </p:sp>
+      <p:sp>
+        <p:nvSpPr>
+          <p:cNvPr id="5" name="內容版面配置區 4"/>
+          <p:cNvSpPr>
+            <a:spLocks noGrp="1"/>
+          </p:cNvSpPr>
+          <p:nvPr>
+            <p:ph idx="1"/>
+          </p:nvPr>
+        </p:nvSpPr>
+        <p:spPr>
+          <a:xfrm>
+            <a:off x="946611" y="858489"/>
+            <a:ext cx="7357804" cy="3647010"/>
+          </a:xfrm>
+        </p:spPr>
+        <p:txBody>
+          <a:bodyPr>
+            <a:normAutofit fontScale="55000" lnSpcReduction="20000"/>
+          </a:bodyPr>
+          <a:lstStyle/>
+          <a:p>
+            <a:r>
+              <a:rPr kumimoji="1" lang="en-US" altLang="zh-TW" sz="3600" dirty="0">
+                <a:latin typeface="Times New Roman" panose="02020603050405020304" pitchFamily="18" charset="0"/>
+                <a:cs typeface="Times New Roman" panose="02020603050405020304" pitchFamily="18" charset="0"/>
+              </a:rPr>
+              <a:t>Definition</a:t>
+            </a:r>
+          </a:p>
+          <a:p>
+            <a:pPr lvl="1"/>
+            <a:r>
+              <a:rPr kumimoji="1" lang="en-US" altLang="zh-TW" sz="2900" dirty="0">
+                <a:latin typeface="Times New Roman" panose="02020603050405020304" pitchFamily="18" charset="0"/>
+                <a:cs typeface="Times New Roman" panose="02020603050405020304" pitchFamily="18" charset="0"/>
+              </a:rPr>
+              <a:t>We run the Guest OS </a:t>
+            </a:r>
+            <a:r>
+              <a:rPr kumimoji="1" lang="en-US" altLang="zh-TW" sz="2900" dirty="0">
+                <a:solidFill>
+                  <a:srgbClr val="FF0000"/>
+                </a:solidFill>
+                <a:latin typeface="Times New Roman" panose="02020603050405020304" pitchFamily="18" charset="0"/>
+                <a:cs typeface="Times New Roman" panose="02020603050405020304" pitchFamily="18" charset="0"/>
+              </a:rPr>
+              <a:t>without modified</a:t>
+            </a:r>
+            <a:r>
+              <a:rPr kumimoji="1" lang="en-US" altLang="zh-TW" sz="2900" dirty="0">
+                <a:latin typeface="Times New Roman" panose="02020603050405020304" pitchFamily="18" charset="0"/>
+                <a:cs typeface="Times New Roman" panose="02020603050405020304" pitchFamily="18" charset="0"/>
+              </a:rPr>
+              <a:t>.</a:t>
+            </a:r>
+          </a:p>
+          <a:p>
+            <a:pPr lvl="1"/>
+            <a:r>
+              <a:rPr kumimoji="1" lang="en-US" altLang="zh-TW" sz="2900" dirty="0">
+                <a:latin typeface="Times New Roman" panose="02020603050405020304" pitchFamily="18" charset="0"/>
+                <a:cs typeface="Times New Roman" panose="02020603050405020304" pitchFamily="18" charset="0"/>
+              </a:rPr>
+              <a:t>The Guest OS </a:t>
+            </a:r>
+            <a:r>
+              <a:rPr kumimoji="1" lang="en-US" altLang="zh-TW" sz="2900" dirty="0">
+                <a:solidFill>
+                  <a:srgbClr val="FF0000"/>
+                </a:solidFill>
+                <a:latin typeface="Times New Roman" panose="02020603050405020304" pitchFamily="18" charset="0"/>
+                <a:cs typeface="Times New Roman" panose="02020603050405020304" pitchFamily="18" charset="0"/>
+              </a:rPr>
+              <a:t>doesn’t realize </a:t>
+            </a:r>
+            <a:r>
+              <a:rPr kumimoji="1" lang="en-US" altLang="zh-TW" sz="2900" dirty="0">
+                <a:latin typeface="Times New Roman" panose="02020603050405020304" pitchFamily="18" charset="0"/>
+                <a:cs typeface="Times New Roman" panose="02020603050405020304" pitchFamily="18" charset="0"/>
+              </a:rPr>
+              <a:t>that it is running above VM rather than physical machine.</a:t>
+            </a:r>
+          </a:p>
+          <a:p>
+            <a:r>
+              <a:rPr kumimoji="1" lang="en-US" altLang="zh-TW" sz="3600" dirty="0">
+                <a:latin typeface="Times New Roman" panose="02020603050405020304" pitchFamily="18" charset="0"/>
+                <a:cs typeface="Times New Roman" panose="02020603050405020304" pitchFamily="18" charset="0"/>
+              </a:rPr>
+              <a:t>Pro</a:t>
+            </a:r>
+          </a:p>
+          <a:p>
+            <a:pPr lvl="1"/>
+            <a:r>
+              <a:rPr kumimoji="1" lang="en-US" altLang="zh-TW" sz="2900" dirty="0">
+                <a:latin typeface="Times New Roman" panose="02020603050405020304" pitchFamily="18" charset="0"/>
+                <a:cs typeface="Times New Roman" panose="02020603050405020304" pitchFamily="18" charset="0"/>
+              </a:rPr>
+              <a:t>User can use any OS what he/she wants to install as Guest OS</a:t>
+            </a:r>
+          </a:p>
+          <a:p>
+            <a:pPr lvl="1"/>
+            <a:r>
+              <a:rPr kumimoji="1" lang="en-US" altLang="zh-TW" sz="2900" dirty="0">
+                <a:latin typeface="Times New Roman" panose="02020603050405020304" pitchFamily="18" charset="0"/>
+                <a:cs typeface="Times New Roman" panose="02020603050405020304" pitchFamily="18" charset="0"/>
+              </a:rPr>
+              <a:t>For those OS which is hard to patch (ex: Windows, because it’s hard to get its source code), user can only install them in full-virtualization environment</a:t>
+            </a:r>
+          </a:p>
+          <a:p>
+            <a:r>
+              <a:rPr kumimoji="1" lang="en-US" altLang="zh-TW" sz="3600" dirty="0">
+                <a:latin typeface="Times New Roman" panose="02020603050405020304" pitchFamily="18" charset="0"/>
+                <a:cs typeface="Times New Roman" panose="02020603050405020304" pitchFamily="18" charset="0"/>
+              </a:rPr>
+              <a:t>Con</a:t>
+            </a:r>
+          </a:p>
+          <a:p>
+            <a:pPr lvl="1"/>
+            <a:r>
+              <a:rPr kumimoji="1" lang="en-US" altLang="zh-TW" sz="2900" dirty="0">
+                <a:latin typeface="Times New Roman" panose="02020603050405020304" pitchFamily="18" charset="0"/>
+                <a:cs typeface="Times New Roman" panose="02020603050405020304" pitchFamily="18" charset="0"/>
+              </a:rPr>
+              <a:t>For non-</a:t>
+            </a:r>
+            <a:r>
+              <a:rPr kumimoji="1" lang="en-US" altLang="zh-TW" sz="2900" dirty="0" err="1">
+                <a:latin typeface="Times New Roman" panose="02020603050405020304" pitchFamily="18" charset="0"/>
+                <a:cs typeface="Times New Roman" panose="02020603050405020304" pitchFamily="18" charset="0"/>
+              </a:rPr>
+              <a:t>virtualizable</a:t>
+            </a:r>
+            <a:r>
+              <a:rPr kumimoji="1" lang="en-US" altLang="zh-TW" sz="2900" dirty="0">
+                <a:latin typeface="Times New Roman" panose="02020603050405020304" pitchFamily="18" charset="0"/>
+                <a:cs typeface="Times New Roman" panose="02020603050405020304" pitchFamily="18" charset="0"/>
+              </a:rPr>
+              <a:t> CPU, running Guest OS without patched critical instruction need use Dynamic Binary Translation in the hypervisor. It costs a lot.</a:t>
+            </a:r>
+          </a:p>
+          <a:p>
+            <a:pPr lvl="1"/>
+            <a:r>
+              <a:rPr kumimoji="1" lang="en-US" altLang="zh-TW" sz="2900" dirty="0">
+                <a:latin typeface="Times New Roman" panose="02020603050405020304" pitchFamily="18" charset="0"/>
+                <a:cs typeface="Times New Roman" panose="02020603050405020304" pitchFamily="18" charset="0"/>
+              </a:rPr>
+              <a:t>Even for the </a:t>
+            </a:r>
+            <a:r>
+              <a:rPr kumimoji="1" lang="en-US" altLang="zh-TW" sz="2900" dirty="0" err="1">
+                <a:latin typeface="Times New Roman" panose="02020603050405020304" pitchFamily="18" charset="0"/>
+                <a:cs typeface="Times New Roman" panose="02020603050405020304" pitchFamily="18" charset="0"/>
+              </a:rPr>
+              <a:t>virtualizable</a:t>
+            </a:r>
+            <a:r>
+              <a:rPr kumimoji="1" lang="en-US" altLang="zh-TW" sz="2900" dirty="0">
+                <a:latin typeface="Times New Roman" panose="02020603050405020304" pitchFamily="18" charset="0"/>
+                <a:cs typeface="Times New Roman" panose="02020603050405020304" pitchFamily="18" charset="0"/>
+              </a:rPr>
+              <a:t> or hardware assistant CPU, running an OS which doesn’t find out its in VM rather in physical machine is still lots of computing resource. Using patched guest OS can avoid these resource wasting. And using full-virtualization environment cannot gain the performance optimization.</a:t>
+            </a:r>
+          </a:p>
+        </p:txBody>
+      </p:sp>
+      <p:sp>
+        <p:nvSpPr>
+          <p:cNvPr id="2" name="灯片编号占位符 1">
+            <a:extLst>
+              <a:ext uri="{FF2B5EF4-FFF2-40B4-BE49-F238E27FC236}">
+                <a16:creationId xmlns:a16="http://schemas.microsoft.com/office/drawing/2014/main" id="{A42411F2-7035-1C9C-FD0C-4E718542028D}"/>
+              </a:ext>
+            </a:extLst>
+          </p:cNvPr>
+          <p:cNvSpPr>
+            <a:spLocks noGrp="1"/>
+          </p:cNvSpPr>
+          <p:nvPr>
+            <p:ph type="sldNum" sz="quarter" idx="10"/>
+          </p:nvPr>
+        </p:nvSpPr>
+        <p:spPr>
+          <a:xfrm>
+            <a:off x="6831013" y="4893471"/>
+            <a:ext cx="2133600" cy="254794"/>
+          </a:xfrm>
+        </p:spPr>
+        <p:txBody>
+          <a:bodyPr/>
+          <a:lstStyle/>
+          <a:p>
+            <a:fld id="{D9B6BDF2-6896-4B98-8776-C18582F63BA5}" type="slidenum">
+              <a:rPr lang="zh-TW" altLang="en-US" smtClean="0"/>
+              <a:pPr/>
+              <a:t>38</a:t>
+            </a:fld>
+            <a:endParaRPr lang="zh-TW" altLang="en-US"/>
+          </a:p>
+        </p:txBody>
+      </p:sp>
+    </p:spTree>
+    <p:extLst>
+      <p:ext uri="{BB962C8B-B14F-4D97-AF65-F5344CB8AC3E}">
+        <p14:creationId xmlns:p14="http://schemas.microsoft.com/office/powerpoint/2010/main" val="2794887352"/>
       </p:ext>
     </p:extLst>
   </p:cSld>
@@ -12590,8 +12800,8 @@
         </p:nvSpPr>
         <p:spPr>
           <a:xfrm>
-            <a:off x="946610" y="79474"/>
-            <a:ext cx="7729079" cy="519113"/>
+            <a:off x="972589" y="79474"/>
+            <a:ext cx="7703101" cy="519113"/>
           </a:xfrm>
         </p:spPr>
         <p:txBody>
@@ -12600,7 +12810,7 @@
           <a:p>
             <a:r>
               <a:rPr kumimoji="1" lang="en-US" altLang="zh-TW" dirty="0"/>
-              <a:t>Full-Virtualization</a:t>
+              <a:t>Para-Virtualization</a:t>
             </a:r>
             <a:endParaRPr kumimoji="1" lang="zh-TW" altLang="en-US" dirty="0"/>
           </a:p>
@@ -12618,18 +12828,18 @@
         </p:nvSpPr>
         <p:spPr>
           <a:xfrm>
-            <a:off x="946611" y="858489"/>
-            <a:ext cx="7357804" cy="3647010"/>
+            <a:off x="1080655" y="835821"/>
+            <a:ext cx="7207134" cy="3586550"/>
           </a:xfrm>
         </p:spPr>
         <p:txBody>
           <a:bodyPr>
-            <a:normAutofit fontScale="55000" lnSpcReduction="20000"/>
+            <a:normAutofit fontScale="70000" lnSpcReduction="20000"/>
           </a:bodyPr>
           <a:lstStyle/>
           <a:p>
             <a:r>
-              <a:rPr kumimoji="1" lang="en-US" altLang="zh-TW" sz="3600" dirty="0">
+              <a:rPr kumimoji="1" lang="en-US" altLang="zh-TW" dirty="0">
                 <a:latin typeface="Times New Roman" panose="02020603050405020304" pitchFamily="18" charset="0"/>
                 <a:cs typeface="Times New Roman" panose="02020603050405020304" pitchFamily="18" charset="0"/>
               </a:rPr>
@@ -12639,24 +12849,24 @@
           <a:p>
             <a:pPr lvl="1"/>
             <a:r>
-              <a:rPr kumimoji="1" lang="en-US" altLang="zh-TW" sz="2900" dirty="0">
-                <a:latin typeface="Times New Roman" panose="02020603050405020304" pitchFamily="18" charset="0"/>
-                <a:cs typeface="Times New Roman" panose="02020603050405020304" pitchFamily="18" charset="0"/>
-              </a:rPr>
-              <a:t>We run the Guest OS </a:t>
-            </a:r>
-            <a:r>
-              <a:rPr kumimoji="1" lang="en-US" altLang="zh-TW" sz="2900" dirty="0">
+              <a:rPr kumimoji="1" lang="en-US" altLang="zh-TW" sz="2300" dirty="0">
+                <a:latin typeface="Times New Roman" panose="02020603050405020304" pitchFamily="18" charset="0"/>
+                <a:cs typeface="Times New Roman" panose="02020603050405020304" pitchFamily="18" charset="0"/>
+              </a:rPr>
+              <a:t>Run the Guest OS which is </a:t>
+            </a:r>
+            <a:r>
+              <a:rPr kumimoji="1" lang="en-US" altLang="zh-TW" sz="2300" dirty="0">
                 <a:solidFill>
                   <a:srgbClr val="FF0000"/>
                 </a:solidFill>
                 <a:latin typeface="Times New Roman" panose="02020603050405020304" pitchFamily="18" charset="0"/>
                 <a:cs typeface="Times New Roman" panose="02020603050405020304" pitchFamily="18" charset="0"/>
               </a:rPr>
-              <a:t>without modified</a:t>
-            </a:r>
-            <a:r>
-              <a:rPr kumimoji="1" lang="en-US" altLang="zh-TW" sz="2900" dirty="0">
+              <a:t>patched for virtualization</a:t>
+            </a:r>
+            <a:r>
+              <a:rPr kumimoji="1" lang="en-US" altLang="zh-TW" sz="2300" dirty="0">
                 <a:latin typeface="Times New Roman" panose="02020603050405020304" pitchFamily="18" charset="0"/>
                 <a:cs typeface="Times New Roman" panose="02020603050405020304" pitchFamily="18" charset="0"/>
               </a:rPr>
@@ -12666,33 +12876,33 @@
           <a:p>
             <a:pPr lvl="1"/>
             <a:r>
-              <a:rPr kumimoji="1" lang="en-US" altLang="zh-TW" sz="2900" dirty="0">
+              <a:rPr kumimoji="1" lang="en-US" altLang="zh-TW" sz="2300" dirty="0">
                 <a:latin typeface="Times New Roman" panose="02020603050405020304" pitchFamily="18" charset="0"/>
                 <a:cs typeface="Times New Roman" panose="02020603050405020304" pitchFamily="18" charset="0"/>
               </a:rPr>
               <a:t>The Guest OS </a:t>
             </a:r>
             <a:r>
-              <a:rPr kumimoji="1" lang="en-US" altLang="zh-TW" sz="2900" dirty="0">
+              <a:rPr kumimoji="1" lang="en-US" altLang="zh-TW" sz="2300" dirty="0">
                 <a:solidFill>
                   <a:srgbClr val="FF0000"/>
                 </a:solidFill>
                 <a:latin typeface="Times New Roman" panose="02020603050405020304" pitchFamily="18" charset="0"/>
                 <a:cs typeface="Times New Roman" panose="02020603050405020304" pitchFamily="18" charset="0"/>
               </a:rPr>
-              <a:t>doesn’t realize </a:t>
-            </a:r>
-            <a:r>
-              <a:rPr kumimoji="1" lang="en-US" altLang="zh-TW" sz="2900" dirty="0">
-                <a:latin typeface="Times New Roman" panose="02020603050405020304" pitchFamily="18" charset="0"/>
-                <a:cs typeface="Times New Roman" panose="02020603050405020304" pitchFamily="18" charset="0"/>
-              </a:rPr>
-              <a:t>that it is running above VM rather than physical machine.</a:t>
-            </a:r>
-          </a:p>
-          <a:p>
-            <a:r>
-              <a:rPr kumimoji="1" lang="en-US" altLang="zh-TW" sz="3600" dirty="0">
+              <a:t>realizes</a:t>
+            </a:r>
+            <a:r>
+              <a:rPr kumimoji="1" lang="en-US" altLang="zh-TW" sz="2300" dirty="0">
+                <a:latin typeface="Times New Roman" panose="02020603050405020304" pitchFamily="18" charset="0"/>
+                <a:cs typeface="Times New Roman" panose="02020603050405020304" pitchFamily="18" charset="0"/>
+              </a:rPr>
+              <a:t> that it is running above VM rather than physical machine.</a:t>
+            </a:r>
+          </a:p>
+          <a:p>
+            <a:r>
+              <a:rPr kumimoji="1" lang="en-US" altLang="zh-TW" dirty="0">
                 <a:latin typeface="Times New Roman" panose="02020603050405020304" pitchFamily="18" charset="0"/>
                 <a:cs typeface="Times New Roman" panose="02020603050405020304" pitchFamily="18" charset="0"/>
               </a:rPr>
@@ -12702,26 +12912,54 @@
           <a:p>
             <a:pPr lvl="1"/>
             <a:r>
-              <a:rPr kumimoji="1" lang="en-US" altLang="zh-TW" sz="2900" dirty="0">
-                <a:latin typeface="Times New Roman" panose="02020603050405020304" pitchFamily="18" charset="0"/>
-                <a:cs typeface="Times New Roman" panose="02020603050405020304" pitchFamily="18" charset="0"/>
-              </a:rPr>
-              <a:t>User can use any OS what he/she wants to install as Guest OS</a:t>
+              <a:rPr kumimoji="1" lang="en-US" altLang="zh-TW" sz="2300" dirty="0">
+                <a:latin typeface="Times New Roman" panose="02020603050405020304" pitchFamily="18" charset="0"/>
+                <a:cs typeface="Times New Roman" panose="02020603050405020304" pitchFamily="18" charset="0"/>
+              </a:rPr>
+              <a:t>For non-</a:t>
+            </a:r>
+            <a:r>
+              <a:rPr kumimoji="1" lang="en-US" altLang="zh-TW" sz="2300" dirty="0" err="1">
+                <a:latin typeface="Times New Roman" panose="02020603050405020304" pitchFamily="18" charset="0"/>
+                <a:cs typeface="Times New Roman" panose="02020603050405020304" pitchFamily="18" charset="0"/>
+              </a:rPr>
+              <a:t>virtualizable</a:t>
+            </a:r>
+            <a:r>
+              <a:rPr kumimoji="1" lang="en-US" altLang="zh-TW" sz="2300" dirty="0">
+                <a:latin typeface="Times New Roman" panose="02020603050405020304" pitchFamily="18" charset="0"/>
+                <a:cs typeface="Times New Roman" panose="02020603050405020304" pitchFamily="18" charset="0"/>
+              </a:rPr>
+              <a:t> CPU, running Guest OS with patched critical instruction can reduce lots of work for hypervisor. Let guest OS run faster.</a:t>
             </a:r>
           </a:p>
           <a:p>
             <a:pPr lvl="1"/>
             <a:r>
-              <a:rPr kumimoji="1" lang="en-US" altLang="zh-TW" sz="2900" dirty="0">
-                <a:latin typeface="Times New Roman" panose="02020603050405020304" pitchFamily="18" charset="0"/>
-                <a:cs typeface="Times New Roman" panose="02020603050405020304" pitchFamily="18" charset="0"/>
-              </a:rPr>
-              <a:t>For those OS which is hard to patch (ex: Windows, because it’s hard to get its source code), user can only install them in full-virtualization environment</a:t>
-            </a:r>
-          </a:p>
-          <a:p>
-            <a:r>
-              <a:rPr kumimoji="1" lang="en-US" altLang="zh-TW" sz="3600" dirty="0">
+              <a:rPr kumimoji="1" lang="en-US" altLang="zh-TW" sz="2300" dirty="0">
+                <a:latin typeface="Times New Roman" panose="02020603050405020304" pitchFamily="18" charset="0"/>
+                <a:cs typeface="Times New Roman" panose="02020603050405020304" pitchFamily="18" charset="0"/>
+              </a:rPr>
+              <a:t>Even for the </a:t>
+            </a:r>
+            <a:r>
+              <a:rPr kumimoji="1" lang="en-US" altLang="zh-TW" sz="2300" dirty="0" err="1">
+                <a:latin typeface="Times New Roman" panose="02020603050405020304" pitchFamily="18" charset="0"/>
+                <a:cs typeface="Times New Roman" panose="02020603050405020304" pitchFamily="18" charset="0"/>
+              </a:rPr>
+              <a:t>virtualizable</a:t>
+            </a:r>
+            <a:r>
+              <a:rPr kumimoji="1" lang="en-US" altLang="zh-TW" sz="2300" dirty="0">
+                <a:latin typeface="Times New Roman" panose="02020603050405020304" pitchFamily="18" charset="0"/>
+                <a:cs typeface="Times New Roman" panose="02020603050405020304" pitchFamily="18" charset="0"/>
+              </a:rPr>
+              <a:t> or hardware assistant CPU, running an OS which doesn’t find out its in VM rather in physical machine is still lots of computing resource. Using patched guest OS can avoid these resource wasting.</a:t>
+            </a:r>
+          </a:p>
+          <a:p>
+            <a:r>
+              <a:rPr kumimoji="1" lang="en-US" altLang="zh-TW" dirty="0">
                 <a:latin typeface="Times New Roman" panose="02020603050405020304" pitchFamily="18" charset="0"/>
                 <a:cs typeface="Times New Roman" panose="02020603050405020304" pitchFamily="18" charset="0"/>
               </a:rPr>
@@ -12731,49 +12969,21 @@
           <a:p>
             <a:pPr lvl="1"/>
             <a:r>
-              <a:rPr kumimoji="1" lang="en-US" altLang="zh-TW" sz="2900" dirty="0">
-                <a:latin typeface="Times New Roman" panose="02020603050405020304" pitchFamily="18" charset="0"/>
-                <a:cs typeface="Times New Roman" panose="02020603050405020304" pitchFamily="18" charset="0"/>
-              </a:rPr>
-              <a:t>For non-</a:t>
-            </a:r>
-            <a:r>
-              <a:rPr kumimoji="1" lang="en-US" altLang="zh-TW" sz="2900" dirty="0" err="1">
-                <a:latin typeface="Times New Roman" panose="02020603050405020304" pitchFamily="18" charset="0"/>
-                <a:cs typeface="Times New Roman" panose="02020603050405020304" pitchFamily="18" charset="0"/>
-              </a:rPr>
-              <a:t>virtualizable</a:t>
-            </a:r>
-            <a:r>
-              <a:rPr kumimoji="1" lang="en-US" altLang="zh-TW" sz="2900" dirty="0">
-                <a:latin typeface="Times New Roman" panose="02020603050405020304" pitchFamily="18" charset="0"/>
-                <a:cs typeface="Times New Roman" panose="02020603050405020304" pitchFamily="18" charset="0"/>
-              </a:rPr>
-              <a:t> CPU, running Guest OS without patched critical instruction need use Dynamic Binary Translation in the hypervisor. It costs a lot.</a:t>
+              <a:rPr kumimoji="1" lang="en-US" altLang="zh-TW" sz="2300" dirty="0">
+                <a:latin typeface="Times New Roman" panose="02020603050405020304" pitchFamily="18" charset="0"/>
+                <a:cs typeface="Times New Roman" panose="02020603050405020304" pitchFamily="18" charset="0"/>
+              </a:rPr>
+              <a:t>User cannot use any OS what he/she wants to install as Guest OS</a:t>
             </a:r>
           </a:p>
           <a:p>
             <a:pPr lvl="1"/>
             <a:r>
-              <a:rPr kumimoji="1" lang="en-US" altLang="zh-TW" sz="2900" dirty="0">
-                <a:latin typeface="Times New Roman" panose="02020603050405020304" pitchFamily="18" charset="0"/>
-                <a:cs typeface="Times New Roman" panose="02020603050405020304" pitchFamily="18" charset="0"/>
-              </a:rPr>
-              <a:t>Even for the </a:t>
-            </a:r>
-            <a:r>
-              <a:rPr kumimoji="1" lang="en-US" altLang="zh-TW" sz="2900" dirty="0" err="1">
-                <a:latin typeface="Times New Roman" panose="02020603050405020304" pitchFamily="18" charset="0"/>
-                <a:cs typeface="Times New Roman" panose="02020603050405020304" pitchFamily="18" charset="0"/>
-              </a:rPr>
-              <a:t>virtualizable</a:t>
-            </a:r>
-            <a:r>
-              <a:rPr kumimoji="1" lang="en-US" altLang="zh-TW" sz="2900" dirty="0">
-                <a:latin typeface="Times New Roman" panose="02020603050405020304" pitchFamily="18" charset="0"/>
-                <a:cs typeface="Times New Roman" panose="02020603050405020304" pitchFamily="18" charset="0"/>
-              </a:rPr>
-              <a:t> or hardware assistant CPU, running an OS which doesn’t find out its in VM rather in physical machine is still lots of computing resource. Using patched guest OS can avoid these resource wasting. And using full-virtualization environment cannot gain the performance optimization.</a:t>
+              <a:rPr kumimoji="1" lang="en-US" altLang="zh-TW" sz="2300" dirty="0">
+                <a:latin typeface="Times New Roman" panose="02020603050405020304" pitchFamily="18" charset="0"/>
+                <a:cs typeface="Times New Roman" panose="02020603050405020304" pitchFamily="18" charset="0"/>
+              </a:rPr>
+              <a:t>For those OS which is hard to patch(ex: Windows, because it’s hard to get its source code), user cannot install them as guest OS.</a:t>
             </a:r>
           </a:p>
         </p:txBody>
@@ -12783,7 +12993,7 @@
           <p:cNvPr id="2" name="灯片编号占位符 1">
             <a:extLst>
               <a:ext uri="{FF2B5EF4-FFF2-40B4-BE49-F238E27FC236}">
-                <a16:creationId xmlns:a16="http://schemas.microsoft.com/office/drawing/2014/main" id="{A42411F2-7035-1C9C-FD0C-4E718542028D}"/>
+                <a16:creationId xmlns:a16="http://schemas.microsoft.com/office/drawing/2014/main" id="{87FCC64D-44DF-94CA-A572-CBA2E34D41EC}"/>
               </a:ext>
             </a:extLst>
           </p:cNvPr>
@@ -12816,7 +13026,7 @@
     </p:spTree>
     <p:extLst>
       <p:ext uri="{BB962C8B-B14F-4D97-AF65-F5344CB8AC3E}">
-        <p14:creationId xmlns:p14="http://schemas.microsoft.com/office/powerpoint/2010/main" val="2794887352"/>
+        <p14:creationId xmlns:p14="http://schemas.microsoft.com/office/powerpoint/2010/main" val="1822305468"/>
       </p:ext>
     </p:extLst>
   </p:cSld>
@@ -14743,271 +14953,6 @@
       </p:grpSpPr>
       <p:sp>
         <p:nvSpPr>
-          <p:cNvPr id="4" name="標題 3"/>
-          <p:cNvSpPr>
-            <a:spLocks noGrp="1"/>
-          </p:cNvSpPr>
-          <p:nvPr>
-            <p:ph type="title"/>
-          </p:nvPr>
-        </p:nvSpPr>
-        <p:spPr>
-          <a:xfrm>
-            <a:off x="972589" y="79474"/>
-            <a:ext cx="7703101" cy="519113"/>
-          </a:xfrm>
-        </p:spPr>
-        <p:txBody>
-          <a:bodyPr/>
-          <a:lstStyle/>
-          <a:p>
-            <a:r>
-              <a:rPr kumimoji="1" lang="en-US" altLang="zh-TW" dirty="0"/>
-              <a:t>Para-Virtualization</a:t>
-            </a:r>
-            <a:endParaRPr kumimoji="1" lang="zh-TW" altLang="en-US" dirty="0"/>
-          </a:p>
-        </p:txBody>
-      </p:sp>
-      <p:sp>
-        <p:nvSpPr>
-          <p:cNvPr id="5" name="內容版面配置區 4"/>
-          <p:cNvSpPr>
-            <a:spLocks noGrp="1"/>
-          </p:cNvSpPr>
-          <p:nvPr>
-            <p:ph idx="1"/>
-          </p:nvPr>
-        </p:nvSpPr>
-        <p:spPr>
-          <a:xfrm>
-            <a:off x="1080655" y="835821"/>
-            <a:ext cx="7207134" cy="3586550"/>
-          </a:xfrm>
-        </p:spPr>
-        <p:txBody>
-          <a:bodyPr>
-            <a:normAutofit fontScale="70000" lnSpcReduction="20000"/>
-          </a:bodyPr>
-          <a:lstStyle/>
-          <a:p>
-            <a:r>
-              <a:rPr kumimoji="1" lang="en-US" altLang="zh-TW" dirty="0">
-                <a:latin typeface="Times New Roman" panose="02020603050405020304" pitchFamily="18" charset="0"/>
-                <a:cs typeface="Times New Roman" panose="02020603050405020304" pitchFamily="18" charset="0"/>
-              </a:rPr>
-              <a:t>Definition</a:t>
-            </a:r>
-          </a:p>
-          <a:p>
-            <a:pPr lvl="1"/>
-            <a:r>
-              <a:rPr kumimoji="1" lang="en-US" altLang="zh-TW" sz="2300" dirty="0">
-                <a:latin typeface="Times New Roman" panose="02020603050405020304" pitchFamily="18" charset="0"/>
-                <a:cs typeface="Times New Roman" panose="02020603050405020304" pitchFamily="18" charset="0"/>
-              </a:rPr>
-              <a:t>Run the Guest OS which is </a:t>
-            </a:r>
-            <a:r>
-              <a:rPr kumimoji="1" lang="en-US" altLang="zh-TW" sz="2300" dirty="0">
-                <a:solidFill>
-                  <a:srgbClr val="FF0000"/>
-                </a:solidFill>
-                <a:latin typeface="Times New Roman" panose="02020603050405020304" pitchFamily="18" charset="0"/>
-                <a:cs typeface="Times New Roman" panose="02020603050405020304" pitchFamily="18" charset="0"/>
-              </a:rPr>
-              <a:t>patched for virtualization</a:t>
-            </a:r>
-            <a:r>
-              <a:rPr kumimoji="1" lang="en-US" altLang="zh-TW" sz="2300" dirty="0">
-                <a:latin typeface="Times New Roman" panose="02020603050405020304" pitchFamily="18" charset="0"/>
-                <a:cs typeface="Times New Roman" panose="02020603050405020304" pitchFamily="18" charset="0"/>
-              </a:rPr>
-              <a:t>.</a:t>
-            </a:r>
-          </a:p>
-          <a:p>
-            <a:pPr lvl="1"/>
-            <a:r>
-              <a:rPr kumimoji="1" lang="en-US" altLang="zh-TW" sz="2300" dirty="0">
-                <a:latin typeface="Times New Roman" panose="02020603050405020304" pitchFamily="18" charset="0"/>
-                <a:cs typeface="Times New Roman" panose="02020603050405020304" pitchFamily="18" charset="0"/>
-              </a:rPr>
-              <a:t>The Guest OS </a:t>
-            </a:r>
-            <a:r>
-              <a:rPr kumimoji="1" lang="en-US" altLang="zh-TW" sz="2300" dirty="0">
-                <a:solidFill>
-                  <a:srgbClr val="FF0000"/>
-                </a:solidFill>
-                <a:latin typeface="Times New Roman" panose="02020603050405020304" pitchFamily="18" charset="0"/>
-                <a:cs typeface="Times New Roman" panose="02020603050405020304" pitchFamily="18" charset="0"/>
-              </a:rPr>
-              <a:t>realizes</a:t>
-            </a:r>
-            <a:r>
-              <a:rPr kumimoji="1" lang="en-US" altLang="zh-TW" sz="2300" dirty="0">
-                <a:latin typeface="Times New Roman" panose="02020603050405020304" pitchFamily="18" charset="0"/>
-                <a:cs typeface="Times New Roman" panose="02020603050405020304" pitchFamily="18" charset="0"/>
-              </a:rPr>
-              <a:t> that it is running above VM rather than physical machine.</a:t>
-            </a:r>
-          </a:p>
-          <a:p>
-            <a:r>
-              <a:rPr kumimoji="1" lang="en-US" altLang="zh-TW" dirty="0">
-                <a:latin typeface="Times New Roman" panose="02020603050405020304" pitchFamily="18" charset="0"/>
-                <a:cs typeface="Times New Roman" panose="02020603050405020304" pitchFamily="18" charset="0"/>
-              </a:rPr>
-              <a:t>Pro</a:t>
-            </a:r>
-          </a:p>
-          <a:p>
-            <a:pPr lvl="1"/>
-            <a:r>
-              <a:rPr kumimoji="1" lang="en-US" altLang="zh-TW" sz="2300" dirty="0">
-                <a:latin typeface="Times New Roman" panose="02020603050405020304" pitchFamily="18" charset="0"/>
-                <a:cs typeface="Times New Roman" panose="02020603050405020304" pitchFamily="18" charset="0"/>
-              </a:rPr>
-              <a:t>For non-</a:t>
-            </a:r>
-            <a:r>
-              <a:rPr kumimoji="1" lang="en-US" altLang="zh-TW" sz="2300" dirty="0" err="1">
-                <a:latin typeface="Times New Roman" panose="02020603050405020304" pitchFamily="18" charset="0"/>
-                <a:cs typeface="Times New Roman" panose="02020603050405020304" pitchFamily="18" charset="0"/>
-              </a:rPr>
-              <a:t>virtualizable</a:t>
-            </a:r>
-            <a:r>
-              <a:rPr kumimoji="1" lang="en-US" altLang="zh-TW" sz="2300" dirty="0">
-                <a:latin typeface="Times New Roman" panose="02020603050405020304" pitchFamily="18" charset="0"/>
-                <a:cs typeface="Times New Roman" panose="02020603050405020304" pitchFamily="18" charset="0"/>
-              </a:rPr>
-              <a:t> CPU, running Guest OS with patched critical instruction can reduce lots of work for hypervisor. Let guest OS run faster.</a:t>
-            </a:r>
-          </a:p>
-          <a:p>
-            <a:pPr lvl="1"/>
-            <a:r>
-              <a:rPr kumimoji="1" lang="en-US" altLang="zh-TW" sz="2300" dirty="0">
-                <a:latin typeface="Times New Roman" panose="02020603050405020304" pitchFamily="18" charset="0"/>
-                <a:cs typeface="Times New Roman" panose="02020603050405020304" pitchFamily="18" charset="0"/>
-              </a:rPr>
-              <a:t>Even for the </a:t>
-            </a:r>
-            <a:r>
-              <a:rPr kumimoji="1" lang="en-US" altLang="zh-TW" sz="2300" dirty="0" err="1">
-                <a:latin typeface="Times New Roman" panose="02020603050405020304" pitchFamily="18" charset="0"/>
-                <a:cs typeface="Times New Roman" panose="02020603050405020304" pitchFamily="18" charset="0"/>
-              </a:rPr>
-              <a:t>virtualizable</a:t>
-            </a:r>
-            <a:r>
-              <a:rPr kumimoji="1" lang="en-US" altLang="zh-TW" sz="2300" dirty="0">
-                <a:latin typeface="Times New Roman" panose="02020603050405020304" pitchFamily="18" charset="0"/>
-                <a:cs typeface="Times New Roman" panose="02020603050405020304" pitchFamily="18" charset="0"/>
-              </a:rPr>
-              <a:t> or hardware assistant CPU, running an OS which doesn’t find out its in VM rather in physical machine is still lots of computing resource. Using patched guest OS can avoid these resource wasting.</a:t>
-            </a:r>
-          </a:p>
-          <a:p>
-            <a:r>
-              <a:rPr kumimoji="1" lang="en-US" altLang="zh-TW" dirty="0">
-                <a:latin typeface="Times New Roman" panose="02020603050405020304" pitchFamily="18" charset="0"/>
-                <a:cs typeface="Times New Roman" panose="02020603050405020304" pitchFamily="18" charset="0"/>
-              </a:rPr>
-              <a:t>Con</a:t>
-            </a:r>
-          </a:p>
-          <a:p>
-            <a:pPr lvl="1"/>
-            <a:r>
-              <a:rPr kumimoji="1" lang="en-US" altLang="zh-TW" sz="2300" dirty="0">
-                <a:latin typeface="Times New Roman" panose="02020603050405020304" pitchFamily="18" charset="0"/>
-                <a:cs typeface="Times New Roman" panose="02020603050405020304" pitchFamily="18" charset="0"/>
-              </a:rPr>
-              <a:t>User cannot use any OS what he/she wants to install as Guest OS</a:t>
-            </a:r>
-          </a:p>
-          <a:p>
-            <a:pPr lvl="1"/>
-            <a:r>
-              <a:rPr kumimoji="1" lang="en-US" altLang="zh-TW" sz="2300" dirty="0">
-                <a:latin typeface="Times New Roman" panose="02020603050405020304" pitchFamily="18" charset="0"/>
-                <a:cs typeface="Times New Roman" panose="02020603050405020304" pitchFamily="18" charset="0"/>
-              </a:rPr>
-              <a:t>For those OS which is hard to patch(ex: Windows, because it’s hard to get its source code), user cannot install them as guest OS.</a:t>
-            </a:r>
-          </a:p>
-        </p:txBody>
-      </p:sp>
-      <p:sp>
-        <p:nvSpPr>
-          <p:cNvPr id="2" name="灯片编号占位符 1">
-            <a:extLst>
-              <a:ext uri="{FF2B5EF4-FFF2-40B4-BE49-F238E27FC236}">
-                <a16:creationId xmlns:a16="http://schemas.microsoft.com/office/drawing/2014/main" id="{87FCC64D-44DF-94CA-A572-CBA2E34D41EC}"/>
-              </a:ext>
-            </a:extLst>
-          </p:cNvPr>
-          <p:cNvSpPr>
-            <a:spLocks noGrp="1"/>
-          </p:cNvSpPr>
-          <p:nvPr>
-            <p:ph type="sldNum" sz="quarter" idx="10"/>
-          </p:nvPr>
-        </p:nvSpPr>
-        <p:spPr>
-          <a:xfrm>
-            <a:off x="6831013" y="4893471"/>
-            <a:ext cx="2133600" cy="254794"/>
-          </a:xfrm>
-        </p:spPr>
-        <p:txBody>
-          <a:bodyPr/>
-          <a:lstStyle/>
-          <a:p>
-            <a:fld id="{D9B6BDF2-6896-4B98-8776-C18582F63BA5}" type="slidenum">
-              <a:rPr lang="zh-TW" altLang="en-US" smtClean="0"/>
-              <a:pPr/>
-              <a:t>40</a:t>
-            </a:fld>
-            <a:endParaRPr lang="zh-TW" altLang="en-US"/>
-          </a:p>
-        </p:txBody>
-      </p:sp>
-    </p:spTree>
-    <p:extLst>
-      <p:ext uri="{BB962C8B-B14F-4D97-AF65-F5344CB8AC3E}">
-        <p14:creationId xmlns:p14="http://schemas.microsoft.com/office/powerpoint/2010/main" val="1822305468"/>
-      </p:ext>
-    </p:extLst>
-  </p:cSld>
-  <p:clrMapOvr>
-    <a:masterClrMapping/>
-  </p:clrMapOvr>
-</p:sld>
-</file>
-
-<file path=ppt/slides/slide41.xml><?xml version="1.0" encoding="utf-8"?>
-<p:sld xmlns:a="http://schemas.openxmlformats.org/drawingml/2006/main" xmlns:r="http://schemas.openxmlformats.org/officeDocument/2006/relationships" xmlns:p="http://schemas.openxmlformats.org/presentationml/2006/main">
-  <p:cSld>
-    <p:spTree>
-      <p:nvGrpSpPr>
-        <p:cNvPr id="1" name=""/>
-        <p:cNvGrpSpPr/>
-        <p:nvPr/>
-      </p:nvGrpSpPr>
-      <p:grpSpPr>
-        <a:xfrm>
-          <a:off x="0" y="0"/>
-          <a:ext cx="0" cy="0"/>
-          <a:chOff x="0" y="0"/>
-          <a:chExt cx="0" cy="0"/>
-        </a:xfrm>
-      </p:grpSpPr>
-      <p:sp>
-        <p:nvSpPr>
           <p:cNvPr id="2" name="標題 1"/>
           <p:cNvSpPr>
             <a:spLocks noGrp="1"/>
@@ -15085,7 +15030,7 @@
             <a:fld id="{D9B6BDF2-6896-4B98-8776-C18582F63BA5}" type="slidenum">
               <a:rPr lang="zh-TW" altLang="en-US" smtClean="0"/>
               <a:pPr/>
-              <a:t>41</a:t>
+              <a:t>40</a:t>
             </a:fld>
             <a:endParaRPr lang="zh-TW" altLang="en-US"/>
           </a:p>
@@ -15104,7 +15049,7 @@
 </p:sld>
 </file>
 
-<file path=ppt/slides/slide42.xml><?xml version="1.0" encoding="utf-8"?>
+<file path=ppt/slides/slide41.xml><?xml version="1.0" encoding="utf-8"?>
 <p:sld xmlns:a="http://schemas.openxmlformats.org/drawingml/2006/main" xmlns:r="http://schemas.openxmlformats.org/officeDocument/2006/relationships" xmlns:p="http://schemas.openxmlformats.org/presentationml/2006/main">
   <p:cSld>
     <p:spTree>
@@ -15264,7 +15209,7 @@
             <a:fld id="{D9B6BDF2-6896-4B98-8776-C18582F63BA5}" type="slidenum">
               <a:rPr lang="zh-TW" altLang="en-US" smtClean="0"/>
               <a:pPr/>
-              <a:t>42</a:t>
+              <a:t>41</a:t>
             </a:fld>
             <a:endParaRPr lang="zh-TW" altLang="en-US"/>
           </a:p>
@@ -15274,6 +15219,113 @@
     <p:extLst>
       <p:ext uri="{BB962C8B-B14F-4D97-AF65-F5344CB8AC3E}">
         <p14:creationId xmlns:p14="http://schemas.microsoft.com/office/powerpoint/2010/main" val="3154645100"/>
+      </p:ext>
+    </p:extLst>
+  </p:cSld>
+  <p:clrMapOvr>
+    <a:masterClrMapping/>
+  </p:clrMapOvr>
+</p:sld>
+</file>
+
+<file path=ppt/slides/slide42.xml><?xml version="1.0" encoding="utf-8"?>
+<p:sld xmlns:a="http://schemas.openxmlformats.org/drawingml/2006/main" xmlns:r="http://schemas.openxmlformats.org/officeDocument/2006/relationships" xmlns:p="http://schemas.openxmlformats.org/presentationml/2006/main">
+  <p:cSld>
+    <p:spTree>
+      <p:nvGrpSpPr>
+        <p:cNvPr id="1" name=""/>
+        <p:cNvGrpSpPr/>
+        <p:nvPr/>
+      </p:nvGrpSpPr>
+      <p:grpSpPr>
+        <a:xfrm>
+          <a:off x="0" y="0"/>
+          <a:ext cx="0" cy="0"/>
+          <a:chOff x="0" y="0"/>
+          <a:chExt cx="0" cy="0"/>
+        </a:xfrm>
+      </p:grpSpPr>
+      <p:sp>
+        <p:nvSpPr>
+          <p:cNvPr id="2" name="標題 1"/>
+          <p:cNvSpPr>
+            <a:spLocks noGrp="1"/>
+          </p:cNvSpPr>
+          <p:nvPr>
+            <p:ph type="title"/>
+          </p:nvPr>
+        </p:nvSpPr>
+        <p:spPr/>
+        <p:txBody>
+          <a:bodyPr/>
+          <a:lstStyle/>
+          <a:p>
+            <a:r>
+              <a:rPr kumimoji="1" lang="en-US" altLang="zh-TW" dirty="0"/>
+              <a:t>Type-1 : bare-metal VMM</a:t>
+            </a:r>
+            <a:endParaRPr kumimoji="1" lang="zh-TW" altLang="en-US" dirty="0"/>
+          </a:p>
+        </p:txBody>
+      </p:sp>
+      <p:sp>
+        <p:nvSpPr>
+          <p:cNvPr id="3" name="文字版面配置區 2"/>
+          <p:cNvSpPr>
+            <a:spLocks noGrp="1"/>
+          </p:cNvSpPr>
+          <p:nvPr>
+            <p:ph type="body" idx="1"/>
+          </p:nvPr>
+        </p:nvSpPr>
+        <p:spPr/>
+        <p:txBody>
+          <a:bodyPr/>
+          <a:lstStyle/>
+          <a:p>
+            <a:endParaRPr kumimoji="1" lang="zh-TW" altLang="en-US"/>
+          </a:p>
+        </p:txBody>
+      </p:sp>
+      <p:sp>
+        <p:nvSpPr>
+          <p:cNvPr id="4" name="灯片编号占位符 1">
+            <a:extLst>
+              <a:ext uri="{FF2B5EF4-FFF2-40B4-BE49-F238E27FC236}">
+                <a16:creationId xmlns:a16="http://schemas.microsoft.com/office/drawing/2014/main" id="{39DBB1F3-EB77-8E48-D207-35624C22FC30}"/>
+              </a:ext>
+            </a:extLst>
+          </p:cNvPr>
+          <p:cNvSpPr>
+            <a:spLocks noGrp="1"/>
+          </p:cNvSpPr>
+          <p:nvPr>
+            <p:ph type="sldNum" sz="quarter" idx="10"/>
+          </p:nvPr>
+        </p:nvSpPr>
+        <p:spPr>
+          <a:xfrm>
+            <a:off x="6831013" y="4893471"/>
+            <a:ext cx="2133600" cy="254794"/>
+          </a:xfrm>
+        </p:spPr>
+        <p:txBody>
+          <a:bodyPr/>
+          <a:lstStyle/>
+          <a:p>
+            <a:fld id="{D9B6BDF2-6896-4B98-8776-C18582F63BA5}" type="slidenum">
+              <a:rPr lang="zh-TW" altLang="en-US" smtClean="0"/>
+              <a:pPr/>
+              <a:t>42</a:t>
+            </a:fld>
+            <a:endParaRPr lang="zh-TW" altLang="en-US"/>
+          </a:p>
+        </p:txBody>
+      </p:sp>
+    </p:spTree>
+    <p:extLst>
+      <p:ext uri="{BB962C8B-B14F-4D97-AF65-F5344CB8AC3E}">
+        <p14:creationId xmlns:p14="http://schemas.microsoft.com/office/powerpoint/2010/main" val="2532469941"/>
       </p:ext>
     </p:extLst>
   </p:cSld>
@@ -15310,113 +15362,6 @@
             <p:ph type="title"/>
           </p:nvPr>
         </p:nvSpPr>
-        <p:spPr/>
-        <p:txBody>
-          <a:bodyPr/>
-          <a:lstStyle/>
-          <a:p>
-            <a:r>
-              <a:rPr kumimoji="1" lang="en-US" altLang="zh-TW" dirty="0"/>
-              <a:t>Type-1 : bare-metal VMM</a:t>
-            </a:r>
-            <a:endParaRPr kumimoji="1" lang="zh-TW" altLang="en-US" dirty="0"/>
-          </a:p>
-        </p:txBody>
-      </p:sp>
-      <p:sp>
-        <p:nvSpPr>
-          <p:cNvPr id="3" name="文字版面配置區 2"/>
-          <p:cNvSpPr>
-            <a:spLocks noGrp="1"/>
-          </p:cNvSpPr>
-          <p:nvPr>
-            <p:ph type="body" idx="1"/>
-          </p:nvPr>
-        </p:nvSpPr>
-        <p:spPr/>
-        <p:txBody>
-          <a:bodyPr/>
-          <a:lstStyle/>
-          <a:p>
-            <a:endParaRPr kumimoji="1" lang="zh-TW" altLang="en-US"/>
-          </a:p>
-        </p:txBody>
-      </p:sp>
-      <p:sp>
-        <p:nvSpPr>
-          <p:cNvPr id="4" name="灯片编号占位符 1">
-            <a:extLst>
-              <a:ext uri="{FF2B5EF4-FFF2-40B4-BE49-F238E27FC236}">
-                <a16:creationId xmlns:a16="http://schemas.microsoft.com/office/drawing/2014/main" id="{39DBB1F3-EB77-8E48-D207-35624C22FC30}"/>
-              </a:ext>
-            </a:extLst>
-          </p:cNvPr>
-          <p:cNvSpPr>
-            <a:spLocks noGrp="1"/>
-          </p:cNvSpPr>
-          <p:nvPr>
-            <p:ph type="sldNum" sz="quarter" idx="10"/>
-          </p:nvPr>
-        </p:nvSpPr>
-        <p:spPr>
-          <a:xfrm>
-            <a:off x="6831013" y="4893471"/>
-            <a:ext cx="2133600" cy="254794"/>
-          </a:xfrm>
-        </p:spPr>
-        <p:txBody>
-          <a:bodyPr/>
-          <a:lstStyle/>
-          <a:p>
-            <a:fld id="{D9B6BDF2-6896-4B98-8776-C18582F63BA5}" type="slidenum">
-              <a:rPr lang="zh-TW" altLang="en-US" smtClean="0"/>
-              <a:pPr/>
-              <a:t>43</a:t>
-            </a:fld>
-            <a:endParaRPr lang="zh-TW" altLang="en-US"/>
-          </a:p>
-        </p:txBody>
-      </p:sp>
-    </p:spTree>
-    <p:extLst>
-      <p:ext uri="{BB962C8B-B14F-4D97-AF65-F5344CB8AC3E}">
-        <p14:creationId xmlns:p14="http://schemas.microsoft.com/office/powerpoint/2010/main" val="2532469941"/>
-      </p:ext>
-    </p:extLst>
-  </p:cSld>
-  <p:clrMapOvr>
-    <a:masterClrMapping/>
-  </p:clrMapOvr>
-</p:sld>
-</file>
-
-<file path=ppt/slides/slide44.xml><?xml version="1.0" encoding="utf-8"?>
-<p:sld xmlns:a="http://schemas.openxmlformats.org/drawingml/2006/main" xmlns:r="http://schemas.openxmlformats.org/officeDocument/2006/relationships" xmlns:p="http://schemas.openxmlformats.org/presentationml/2006/main">
-  <p:cSld>
-    <p:spTree>
-      <p:nvGrpSpPr>
-        <p:cNvPr id="1" name=""/>
-        <p:cNvGrpSpPr/>
-        <p:nvPr/>
-      </p:nvGrpSpPr>
-      <p:grpSpPr>
-        <a:xfrm>
-          <a:off x="0" y="0"/>
-          <a:ext cx="0" cy="0"/>
-          <a:chOff x="0" y="0"/>
-          <a:chExt cx="0" cy="0"/>
-        </a:xfrm>
-      </p:grpSpPr>
-      <p:sp>
-        <p:nvSpPr>
-          <p:cNvPr id="2" name="標題 1"/>
-          <p:cNvSpPr>
-            <a:spLocks noGrp="1"/>
-          </p:cNvSpPr>
-          <p:nvPr>
-            <p:ph type="title"/>
-          </p:nvPr>
-        </p:nvSpPr>
         <p:spPr>
           <a:xfrm>
             <a:off x="889462" y="108349"/>
@@ -15541,7 +15486,7 @@
             <a:fld id="{D9B6BDF2-6896-4B98-8776-C18582F63BA5}" type="slidenum">
               <a:rPr lang="zh-TW" altLang="en-US" smtClean="0"/>
               <a:pPr/>
-              <a:t>44</a:t>
+              <a:t>43</a:t>
             </a:fld>
             <a:endParaRPr lang="zh-TW" altLang="en-US"/>
           </a:p>
@@ -16449,7 +16394,7 @@
 </p:sld>
 </file>
 
-<file path=ppt/slides/slide45.xml><?xml version="1.0" encoding="utf-8"?>
+<file path=ppt/slides/slide44.xml><?xml version="1.0" encoding="utf-8"?>
 <p:sld xmlns:a="http://schemas.openxmlformats.org/drawingml/2006/main" xmlns:r="http://schemas.openxmlformats.org/officeDocument/2006/relationships" xmlns:p="http://schemas.openxmlformats.org/presentationml/2006/main">
   <p:cSld>
     <p:spTree>
@@ -16537,7 +16482,7 @@
             <a:fld id="{D9B6BDF2-6896-4B98-8776-C18582F63BA5}" type="slidenum">
               <a:rPr lang="zh-TW" altLang="en-US" smtClean="0"/>
               <a:pPr/>
-              <a:t>45</a:t>
+              <a:t>44</a:t>
             </a:fld>
             <a:endParaRPr lang="zh-TW" altLang="en-US"/>
           </a:p>
@@ -16556,7 +16501,7 @@
 </p:sld>
 </file>
 
-<file path=ppt/slides/slide46.xml><?xml version="1.0" encoding="utf-8"?>
+<file path=ppt/slides/slide45.xml><?xml version="1.0" encoding="utf-8"?>
 <p:sld xmlns:a="http://schemas.openxmlformats.org/drawingml/2006/main" xmlns:r="http://schemas.openxmlformats.org/officeDocument/2006/relationships" xmlns:p="http://schemas.openxmlformats.org/presentationml/2006/main">
   <p:cSld>
     <p:spTree>
@@ -16613,7 +16558,7 @@
         </p:nvSpPr>
         <p:spPr>
           <a:xfrm>
-            <a:off x="457200" y="819215"/>
+            <a:off x="962788" y="816851"/>
             <a:ext cx="8229600" cy="3671888"/>
           </a:xfrm>
         </p:spPr>
@@ -16726,7 +16671,7 @@
             <a:fld id="{D9B6BDF2-6896-4B98-8776-C18582F63BA5}" type="slidenum">
               <a:rPr lang="zh-TW" altLang="en-US" smtClean="0"/>
               <a:pPr/>
-              <a:t>46</a:t>
+              <a:t>45</a:t>
             </a:fld>
             <a:endParaRPr lang="zh-TW" altLang="en-US"/>
           </a:p>
@@ -18039,7 +17984,7 @@
 </p:sld>
 </file>
 
-<file path=ppt/slides/slide47.xml><?xml version="1.0" encoding="utf-8"?>
+<file path=ppt/slides/slide46.xml><?xml version="1.0" encoding="utf-8"?>
 <p:sld xmlns:a="http://schemas.openxmlformats.org/drawingml/2006/main" xmlns:r="http://schemas.openxmlformats.org/officeDocument/2006/relationships" xmlns:p="http://schemas.openxmlformats.org/presentationml/2006/main">
   <p:cSld>
     <p:spTree>
@@ -24685,7 +24630,7 @@
             <a:fld id="{D9B6BDF2-6896-4B98-8776-C18582F63BA5}" type="slidenum">
               <a:rPr lang="zh-TW" altLang="en-US" smtClean="0"/>
               <a:pPr/>
-              <a:t>47</a:t>
+              <a:t>46</a:t>
             </a:fld>
             <a:endParaRPr lang="zh-TW" altLang="en-US"/>
           </a:p>

</xml_diff>